<commit_message>
Excel Formula, Practice File
</commit_message>
<xml_diff>
--- a/Presentations Files/Day3.pptx
+++ b/Presentations Files/Day3.pptx
@@ -6,10 +6,10 @@
   </p:sldMasterIdLst>
   <p:sldIdLst>
     <p:sldId id="256" r:id="rId2"/>
-    <p:sldId id="262" r:id="rId3"/>
-    <p:sldId id="265" r:id="rId4"/>
-    <p:sldId id="263" r:id="rId5"/>
-    <p:sldId id="267" r:id="rId6"/>
+    <p:sldId id="263" r:id="rId3"/>
+    <p:sldId id="267" r:id="rId4"/>
+    <p:sldId id="262" r:id="rId5"/>
+    <p:sldId id="265" r:id="rId6"/>
     <p:sldId id="264" r:id="rId7"/>
     <p:sldId id="266" r:id="rId8"/>
   </p:sldIdLst>
@@ -288,7 +288,7 @@
           <a:p>
             <a:fld id="{94D45B10-2123-4E14-879F-26AED869B83E}" type="datetimeFigureOut">
               <a:rPr lang="en-IN" smtClean="0"/>
-              <a:t>25-03-2026</a:t>
+              <a:t>30-03-2026</a:t>
             </a:fld>
             <a:endParaRPr lang="en-IN"/>
           </a:p>
@@ -555,7 +555,7 @@
           <a:p>
             <a:fld id="{94D45B10-2123-4E14-879F-26AED869B83E}" type="datetimeFigureOut">
               <a:rPr lang="en-IN" smtClean="0"/>
-              <a:t>25-03-2026</a:t>
+              <a:t>30-03-2026</a:t>
             </a:fld>
             <a:endParaRPr lang="en-IN"/>
           </a:p>
@@ -786,7 +786,7 @@
           <a:p>
             <a:fld id="{94D45B10-2123-4E14-879F-26AED869B83E}" type="datetimeFigureOut">
               <a:rPr lang="en-IN" smtClean="0"/>
-              <a:t>25-03-2026</a:t>
+              <a:t>30-03-2026</a:t>
             </a:fld>
             <a:endParaRPr lang="en-IN"/>
           </a:p>
@@ -1096,7 +1096,7 @@
           <a:p>
             <a:fld id="{94D45B10-2123-4E14-879F-26AED869B83E}" type="datetimeFigureOut">
               <a:rPr lang="en-IN" smtClean="0"/>
-              <a:t>25-03-2026</a:t>
+              <a:t>30-03-2026</a:t>
             </a:fld>
             <a:endParaRPr lang="en-IN"/>
           </a:p>
@@ -1569,7 +1569,7 @@
           <a:p>
             <a:fld id="{94D45B10-2123-4E14-879F-26AED869B83E}" type="datetimeFigureOut">
               <a:rPr lang="en-IN" smtClean="0"/>
-              <a:t>25-03-2026</a:t>
+              <a:t>30-03-2026</a:t>
             </a:fld>
             <a:endParaRPr lang="en-IN"/>
           </a:p>
@@ -2116,7 +2116,7 @@
           <a:p>
             <a:fld id="{94D45B10-2123-4E14-879F-26AED869B83E}" type="datetimeFigureOut">
               <a:rPr lang="en-IN" smtClean="0"/>
-              <a:t>25-03-2026</a:t>
+              <a:t>30-03-2026</a:t>
             </a:fld>
             <a:endParaRPr lang="en-IN"/>
           </a:p>
@@ -2890,7 +2890,7 @@
           <a:p>
             <a:fld id="{94D45B10-2123-4E14-879F-26AED869B83E}" type="datetimeFigureOut">
               <a:rPr lang="en-IN" smtClean="0"/>
-              <a:t>25-03-2026</a:t>
+              <a:t>30-03-2026</a:t>
             </a:fld>
             <a:endParaRPr lang="en-IN"/>
           </a:p>
@@ -3065,7 +3065,7 @@
           <a:p>
             <a:fld id="{94D45B10-2123-4E14-879F-26AED869B83E}" type="datetimeFigureOut">
               <a:rPr lang="en-IN" smtClean="0"/>
-              <a:t>25-03-2026</a:t>
+              <a:t>30-03-2026</a:t>
             </a:fld>
             <a:endParaRPr lang="en-IN"/>
           </a:p>
@@ -3288,7 +3288,7 @@
           <a:p>
             <a:fld id="{94D45B10-2123-4E14-879F-26AED869B83E}" type="datetimeFigureOut">
               <a:rPr lang="en-IN" smtClean="0"/>
-              <a:t>25-03-2026</a:t>
+              <a:t>30-03-2026</a:t>
             </a:fld>
             <a:endParaRPr lang="en-IN"/>
           </a:p>
@@ -3468,7 +3468,7 @@
           <a:p>
             <a:fld id="{94D45B10-2123-4E14-879F-26AED869B83E}" type="datetimeFigureOut">
               <a:rPr lang="en-IN" smtClean="0"/>
-              <a:t>25-03-2026</a:t>
+              <a:t>30-03-2026</a:t>
             </a:fld>
             <a:endParaRPr lang="en-IN"/>
           </a:p>
@@ -3757,7 +3757,7 @@
           <a:p>
             <a:fld id="{94D45B10-2123-4E14-879F-26AED869B83E}" type="datetimeFigureOut">
               <a:rPr lang="en-IN" smtClean="0"/>
-              <a:t>25-03-2026</a:t>
+              <a:t>30-03-2026</a:t>
             </a:fld>
             <a:endParaRPr lang="en-IN"/>
           </a:p>
@@ -3999,7 +3999,7 @@
           <a:p>
             <a:fld id="{94D45B10-2123-4E14-879F-26AED869B83E}" type="datetimeFigureOut">
               <a:rPr lang="en-IN" smtClean="0"/>
-              <a:t>25-03-2026</a:t>
+              <a:t>30-03-2026</a:t>
             </a:fld>
             <a:endParaRPr lang="en-IN"/>
           </a:p>
@@ -4378,7 +4378,7 @@
           <a:p>
             <a:fld id="{94D45B10-2123-4E14-879F-26AED869B83E}" type="datetimeFigureOut">
               <a:rPr lang="en-IN" smtClean="0"/>
-              <a:t>25-03-2026</a:t>
+              <a:t>30-03-2026</a:t>
             </a:fld>
             <a:endParaRPr lang="en-IN"/>
           </a:p>
@@ -4496,7 +4496,7 @@
           <a:p>
             <a:fld id="{94D45B10-2123-4E14-879F-26AED869B83E}" type="datetimeFigureOut">
               <a:rPr lang="en-IN" smtClean="0"/>
-              <a:t>25-03-2026</a:t>
+              <a:t>30-03-2026</a:t>
             </a:fld>
             <a:endParaRPr lang="en-IN"/>
           </a:p>
@@ -4591,7 +4591,7 @@
           <a:p>
             <a:fld id="{94D45B10-2123-4E14-879F-26AED869B83E}" type="datetimeFigureOut">
               <a:rPr lang="en-IN" smtClean="0"/>
-              <a:t>25-03-2026</a:t>
+              <a:t>30-03-2026</a:t>
             </a:fld>
             <a:endParaRPr lang="en-IN"/>
           </a:p>
@@ -4840,7 +4840,7 @@
           <a:p>
             <a:fld id="{94D45B10-2123-4E14-879F-26AED869B83E}" type="datetimeFigureOut">
               <a:rPr lang="en-IN" smtClean="0"/>
-              <a:t>25-03-2026</a:t>
+              <a:t>30-03-2026</a:t>
             </a:fld>
             <a:endParaRPr lang="en-IN"/>
           </a:p>
@@ -5097,7 +5097,7 @@
           <a:p>
             <a:fld id="{94D45B10-2123-4E14-879F-26AED869B83E}" type="datetimeFigureOut">
               <a:rPr lang="en-IN" smtClean="0"/>
-              <a:t>25-03-2026</a:t>
+              <a:t>30-03-2026</a:t>
             </a:fld>
             <a:endParaRPr lang="en-IN"/>
           </a:p>
@@ -5340,7 +5340,7 @@
           <a:p>
             <a:fld id="{94D45B10-2123-4E14-879F-26AED869B83E}" type="datetimeFigureOut">
               <a:rPr lang="en-IN" smtClean="0"/>
-              <a:t>25-03-2026</a:t>
+              <a:t>30-03-2026</a:t>
             </a:fld>
             <a:endParaRPr lang="en-IN"/>
           </a:p>
@@ -6020,47 +6020,12 @@
           <a:chExt cx="0" cy="0"/>
         </a:xfrm>
       </p:grpSpPr>
-      <p:pic>
-        <p:nvPicPr>
-          <p:cNvPr id="7" name="Picture 6">
+      <p:sp>
+        <p:nvSpPr>
+          <p:cNvPr id="2" name="Oval 1">
             <a:extLst>
               <a:ext uri="{FF2B5EF4-FFF2-40B4-BE49-F238E27FC236}">
-                <a16:creationId xmlns:a16="http://schemas.microsoft.com/office/drawing/2014/main" id="{46525F87-7270-4174-9EC6-D95F6D145A50}"/>
-              </a:ext>
-            </a:extLst>
-          </p:cNvPr>
-          <p:cNvPicPr>
-            <a:picLocks noChangeAspect="1"/>
-          </p:cNvPicPr>
-          <p:nvPr/>
-        </p:nvPicPr>
-        <p:blipFill rotWithShape="1">
-          <a:blip r:embed="rId2">
-            <a:extLst>
-              <a:ext uri="{28A0092B-C50C-407E-A947-70E740481C1C}">
-                <a14:useLocalDpi xmlns:a14="http://schemas.microsoft.com/office/drawing/2010/main" val="0"/>
-              </a:ext>
-            </a:extLst>
-          </a:blip>
-          <a:srcRect t="3011" b="28029"/>
-          <a:stretch/>
-        </p:blipFill>
-        <p:spPr>
-          <a:xfrm>
-            <a:off x="5363399" y="0"/>
-            <a:ext cx="6828601" cy="6858000"/>
-          </a:xfrm>
-          <a:prstGeom prst="rect">
-            <a:avLst/>
-          </a:prstGeom>
-        </p:spPr>
-      </p:pic>
-      <p:sp>
-        <p:nvSpPr>
-          <p:cNvPr id="8" name="Oval 7">
-            <a:extLst>
-              <a:ext uri="{FF2B5EF4-FFF2-40B4-BE49-F238E27FC236}">
-                <a16:creationId xmlns:a16="http://schemas.microsoft.com/office/drawing/2014/main" id="{DD19CF32-87B5-402D-8EA7-7E9BA1060AE0}"/>
+                <a16:creationId xmlns:a16="http://schemas.microsoft.com/office/drawing/2014/main" id="{14817208-43A0-4277-ACFA-AFE30CEF256B}"/>
               </a:ext>
             </a:extLst>
           </p:cNvPr>
@@ -6069,7 +6034,7 @@
         </p:nvSpPr>
         <p:spPr>
           <a:xfrm>
-            <a:off x="1064870" y="1705819"/>
+            <a:off x="4137389" y="3342640"/>
             <a:ext cx="3472405" cy="3446362"/>
           </a:xfrm>
           <a:prstGeom prst="ellipse">
@@ -6117,7 +6082,7 @@
                   <a:srgbClr val="FF0000"/>
                 </a:solidFill>
               </a:rPr>
-              <a:t>Task 1 : Create A Resume</a:t>
+              <a:t>Task 1 : Perform These Operations</a:t>
             </a:r>
             <a:endParaRPr lang="en-IN" sz="2400" b="1" dirty="0">
               <a:solidFill>
@@ -6127,10 +6092,875 @@
           </a:p>
         </p:txBody>
       </p:sp>
+      <p:graphicFrame>
+        <p:nvGraphicFramePr>
+          <p:cNvPr id="8" name="Table 7">
+            <a:extLst>
+              <a:ext uri="{FF2B5EF4-FFF2-40B4-BE49-F238E27FC236}">
+                <a16:creationId xmlns:a16="http://schemas.microsoft.com/office/drawing/2014/main" id="{C202F8E2-4D4E-4EA8-BD29-28B1D7D51794}"/>
+              </a:ext>
+            </a:extLst>
+          </p:cNvPr>
+          <p:cNvGraphicFramePr>
+            <a:graphicFrameLocks noGrp="1"/>
+          </p:cNvGraphicFramePr>
+          <p:nvPr>
+            <p:extLst>
+              <p:ext uri="{D42A27DB-BD31-4B8C-83A1-F6EECF244321}">
+                <p14:modId xmlns:p14="http://schemas.microsoft.com/office/powerpoint/2010/main" val="3451268372"/>
+              </p:ext>
+            </p:extLst>
+          </p:nvPr>
+        </p:nvGraphicFramePr>
+        <p:xfrm>
+          <a:off x="609600" y="1648542"/>
+          <a:ext cx="10687667" cy="1694096"/>
+        </p:xfrm>
+        <a:graphic>
+          <a:graphicData uri="http://schemas.openxmlformats.org/drawingml/2006/table">
+            <a:tbl>
+              <a:tblPr>
+                <a:tableStyleId>{5C22544A-7EE6-4342-B048-85BDC9FD1C3A}</a:tableStyleId>
+              </a:tblPr>
+              <a:tblGrid>
+                <a:gridCol w="2084439">
+                  <a:extLst>
+                    <a:ext uri="{9D8B030D-6E8A-4147-A177-3AD203B41FA5}">
+                      <a16:colId xmlns:a16="http://schemas.microsoft.com/office/drawing/2014/main" val="1932000432"/>
+                    </a:ext>
+                  </a:extLst>
+                </a:gridCol>
+                <a:gridCol w="983226">
+                  <a:extLst>
+                    <a:ext uri="{9D8B030D-6E8A-4147-A177-3AD203B41FA5}">
+                      <a16:colId xmlns:a16="http://schemas.microsoft.com/office/drawing/2014/main" val="1565188398"/>
+                    </a:ext>
+                  </a:extLst>
+                </a:gridCol>
+                <a:gridCol w="1091380">
+                  <a:extLst>
+                    <a:ext uri="{9D8B030D-6E8A-4147-A177-3AD203B41FA5}">
+                      <a16:colId xmlns:a16="http://schemas.microsoft.com/office/drawing/2014/main" val="2465955744"/>
+                    </a:ext>
+                  </a:extLst>
+                </a:gridCol>
+                <a:gridCol w="891172">
+                  <a:extLst>
+                    <a:ext uri="{9D8B030D-6E8A-4147-A177-3AD203B41FA5}">
+                      <a16:colId xmlns:a16="http://schemas.microsoft.com/office/drawing/2014/main" val="3765331658"/>
+                    </a:ext>
+                  </a:extLst>
+                </a:gridCol>
+                <a:gridCol w="1127490">
+                  <a:extLst>
+                    <a:ext uri="{9D8B030D-6E8A-4147-A177-3AD203B41FA5}">
+                      <a16:colId xmlns:a16="http://schemas.microsoft.com/office/drawing/2014/main" val="2263151412"/>
+                    </a:ext>
+                  </a:extLst>
+                </a:gridCol>
+                <a:gridCol w="1127490">
+                  <a:extLst>
+                    <a:ext uri="{9D8B030D-6E8A-4147-A177-3AD203B41FA5}">
+                      <a16:colId xmlns:a16="http://schemas.microsoft.com/office/drawing/2014/main" val="351993065"/>
+                    </a:ext>
+                  </a:extLst>
+                </a:gridCol>
+                <a:gridCol w="1127490">
+                  <a:extLst>
+                    <a:ext uri="{9D8B030D-6E8A-4147-A177-3AD203B41FA5}">
+                      <a16:colId xmlns:a16="http://schemas.microsoft.com/office/drawing/2014/main" val="3807918826"/>
+                    </a:ext>
+                  </a:extLst>
+                </a:gridCol>
+                <a:gridCol w="1127490">
+                  <a:extLst>
+                    <a:ext uri="{9D8B030D-6E8A-4147-A177-3AD203B41FA5}">
+                      <a16:colId xmlns:a16="http://schemas.microsoft.com/office/drawing/2014/main" val="2918428372"/>
+                    </a:ext>
+                  </a:extLst>
+                </a:gridCol>
+                <a:gridCol w="1127490">
+                  <a:extLst>
+                    <a:ext uri="{9D8B030D-6E8A-4147-A177-3AD203B41FA5}">
+                      <a16:colId xmlns:a16="http://schemas.microsoft.com/office/drawing/2014/main" val="1805612043"/>
+                    </a:ext>
+                  </a:extLst>
+                </a:gridCol>
+              </a:tblGrid>
+              <a:tr h="423524">
+                <a:tc>
+                  <a:txBody>
+                    <a:bodyPr/>
+                    <a:lstStyle/>
+                    <a:p>
+                      <a:pPr algn="ctr" fontAlgn="t"/>
+                      <a:r>
+                        <a:rPr lang="en-IN" sz="2000" b="1" u="none" strike="noStrike">
+                          <a:effectLst/>
+                        </a:rPr>
+                        <a:t>Student's Name</a:t>
+                      </a:r>
+                      <a:endParaRPr lang="en-IN" sz="2000" b="1" i="0" u="none" strike="noStrike">
+                        <a:solidFill>
+                          <a:srgbClr val="000000"/>
+                        </a:solidFill>
+                        <a:effectLst/>
+                        <a:latin typeface="Calibri" panose="020F0502020204030204" pitchFamily="34" charset="0"/>
+                      </a:endParaRPr>
+                    </a:p>
+                  </a:txBody>
+                  <a:tcPr marL="7620" marR="7620" marT="7620" marB="0"/>
+                </a:tc>
+                <a:tc>
+                  <a:txBody>
+                    <a:bodyPr/>
+                    <a:lstStyle/>
+                    <a:p>
+                      <a:pPr algn="ctr" fontAlgn="t"/>
+                      <a:r>
+                        <a:rPr lang="en-IN" sz="2000" b="1" u="none" strike="noStrike">
+                          <a:effectLst/>
+                        </a:rPr>
+                        <a:t>English</a:t>
+                      </a:r>
+                      <a:endParaRPr lang="en-IN" sz="2000" b="1" i="0" u="none" strike="noStrike">
+                        <a:solidFill>
+                          <a:srgbClr val="000000"/>
+                        </a:solidFill>
+                        <a:effectLst/>
+                        <a:latin typeface="Calibri" panose="020F0502020204030204" pitchFamily="34" charset="0"/>
+                      </a:endParaRPr>
+                    </a:p>
+                  </a:txBody>
+                  <a:tcPr marL="7620" marR="7620" marT="7620" marB="0"/>
+                </a:tc>
+                <a:tc>
+                  <a:txBody>
+                    <a:bodyPr/>
+                    <a:lstStyle/>
+                    <a:p>
+                      <a:pPr algn="ctr" fontAlgn="t"/>
+                      <a:r>
+                        <a:rPr lang="en-IN" sz="2000" b="1" u="none" strike="noStrike">
+                          <a:effectLst/>
+                        </a:rPr>
+                        <a:t>Hindi</a:t>
+                      </a:r>
+                      <a:endParaRPr lang="en-IN" sz="2000" b="1" i="0" u="none" strike="noStrike">
+                        <a:solidFill>
+                          <a:srgbClr val="000000"/>
+                        </a:solidFill>
+                        <a:effectLst/>
+                        <a:latin typeface="Calibri" panose="020F0502020204030204" pitchFamily="34" charset="0"/>
+                      </a:endParaRPr>
+                    </a:p>
+                  </a:txBody>
+                  <a:tcPr marL="7620" marR="7620" marT="7620" marB="0"/>
+                </a:tc>
+                <a:tc>
+                  <a:txBody>
+                    <a:bodyPr/>
+                    <a:lstStyle/>
+                    <a:p>
+                      <a:pPr algn="ctr" fontAlgn="t"/>
+                      <a:r>
+                        <a:rPr lang="en-IN" sz="2000" b="1" u="none" strike="noStrike" dirty="0">
+                          <a:effectLst/>
+                        </a:rPr>
+                        <a:t>Math</a:t>
+                      </a:r>
+                      <a:endParaRPr lang="en-IN" sz="2000" b="1" i="0" u="none" strike="noStrike" dirty="0">
+                        <a:solidFill>
+                          <a:srgbClr val="000000"/>
+                        </a:solidFill>
+                        <a:effectLst/>
+                        <a:latin typeface="Calibri" panose="020F0502020204030204" pitchFamily="34" charset="0"/>
+                      </a:endParaRPr>
+                    </a:p>
+                  </a:txBody>
+                  <a:tcPr marL="7620" marR="7620" marT="7620" marB="0"/>
+                </a:tc>
+                <a:tc>
+                  <a:txBody>
+                    <a:bodyPr/>
+                    <a:lstStyle/>
+                    <a:p>
+                      <a:pPr algn="ctr" fontAlgn="t"/>
+                      <a:r>
+                        <a:rPr lang="en-IN" sz="2000" b="1" u="none" strike="noStrike">
+                          <a:effectLst/>
+                        </a:rPr>
+                        <a:t>Total</a:t>
+                      </a:r>
+                      <a:endParaRPr lang="en-IN" sz="2000" b="1" i="0" u="none" strike="noStrike">
+                        <a:solidFill>
+                          <a:srgbClr val="000000"/>
+                        </a:solidFill>
+                        <a:effectLst/>
+                        <a:latin typeface="Calibri" panose="020F0502020204030204" pitchFamily="34" charset="0"/>
+                      </a:endParaRPr>
+                    </a:p>
+                  </a:txBody>
+                  <a:tcPr marL="7620" marR="7620" marT="7620" marB="0"/>
+                </a:tc>
+                <a:tc>
+                  <a:txBody>
+                    <a:bodyPr/>
+                    <a:lstStyle/>
+                    <a:p>
+                      <a:pPr algn="ctr" fontAlgn="t"/>
+                      <a:r>
+                        <a:rPr lang="en-IN" sz="2000" b="1" u="none" strike="noStrike">
+                          <a:effectLst/>
+                        </a:rPr>
+                        <a:t>Min</a:t>
+                      </a:r>
+                      <a:endParaRPr lang="en-IN" sz="2000" b="1" i="0" u="none" strike="noStrike">
+                        <a:solidFill>
+                          <a:srgbClr val="000000"/>
+                        </a:solidFill>
+                        <a:effectLst/>
+                        <a:latin typeface="Calibri" panose="020F0502020204030204" pitchFamily="34" charset="0"/>
+                      </a:endParaRPr>
+                    </a:p>
+                  </a:txBody>
+                  <a:tcPr marL="7620" marR="7620" marT="7620" marB="0"/>
+                </a:tc>
+                <a:tc>
+                  <a:txBody>
+                    <a:bodyPr/>
+                    <a:lstStyle/>
+                    <a:p>
+                      <a:pPr algn="ctr" fontAlgn="t"/>
+                      <a:r>
+                        <a:rPr lang="en-IN" sz="2000" b="1" u="none" strike="noStrike">
+                          <a:effectLst/>
+                        </a:rPr>
+                        <a:t>Max</a:t>
+                      </a:r>
+                      <a:endParaRPr lang="en-IN" sz="2000" b="1" i="0" u="none" strike="noStrike">
+                        <a:solidFill>
+                          <a:srgbClr val="000000"/>
+                        </a:solidFill>
+                        <a:effectLst/>
+                        <a:latin typeface="Calibri" panose="020F0502020204030204" pitchFamily="34" charset="0"/>
+                      </a:endParaRPr>
+                    </a:p>
+                  </a:txBody>
+                  <a:tcPr marL="7620" marR="7620" marT="7620" marB="0"/>
+                </a:tc>
+                <a:tc>
+                  <a:txBody>
+                    <a:bodyPr/>
+                    <a:lstStyle/>
+                    <a:p>
+                      <a:pPr algn="ctr" fontAlgn="t"/>
+                      <a:r>
+                        <a:rPr lang="en-IN" sz="2000" b="1" u="none" strike="noStrike">
+                          <a:effectLst/>
+                        </a:rPr>
+                        <a:t>Average</a:t>
+                      </a:r>
+                      <a:endParaRPr lang="en-IN" sz="2000" b="1" i="0" u="none" strike="noStrike">
+                        <a:solidFill>
+                          <a:srgbClr val="000000"/>
+                        </a:solidFill>
+                        <a:effectLst/>
+                        <a:latin typeface="Calibri" panose="020F0502020204030204" pitchFamily="34" charset="0"/>
+                      </a:endParaRPr>
+                    </a:p>
+                  </a:txBody>
+                  <a:tcPr marL="7620" marR="7620" marT="7620" marB="0"/>
+                </a:tc>
+                <a:tc>
+                  <a:txBody>
+                    <a:bodyPr/>
+                    <a:lstStyle/>
+                    <a:p>
+                      <a:pPr algn="ctr" fontAlgn="t"/>
+                      <a:r>
+                        <a:rPr lang="en-IN" sz="2000" b="1" u="none" strike="noStrike">
+                          <a:effectLst/>
+                        </a:rPr>
+                        <a:t>Photo</a:t>
+                      </a:r>
+                      <a:endParaRPr lang="en-IN" sz="2000" b="1" i="0" u="none" strike="noStrike">
+                        <a:solidFill>
+                          <a:srgbClr val="000000"/>
+                        </a:solidFill>
+                        <a:effectLst/>
+                        <a:latin typeface="Calibri" panose="020F0502020204030204" pitchFamily="34" charset="0"/>
+                      </a:endParaRPr>
+                    </a:p>
+                  </a:txBody>
+                  <a:tcPr marL="7620" marR="7620" marT="7620" marB="0"/>
+                </a:tc>
+                <a:extLst>
+                  <a:ext uri="{0D108BD9-81ED-4DB2-BD59-A6C34878D82A}">
+                    <a16:rowId xmlns:a16="http://schemas.microsoft.com/office/drawing/2014/main" val="1933412555"/>
+                  </a:ext>
+                </a:extLst>
+              </a:tr>
+              <a:tr h="423524">
+                <a:tc>
+                  <a:txBody>
+                    <a:bodyPr/>
+                    <a:lstStyle/>
+                    <a:p>
+                      <a:pPr algn="l" fontAlgn="b"/>
+                      <a:r>
+                        <a:rPr lang="en-IN" sz="2000" b="1" u="none" strike="noStrike">
+                          <a:effectLst/>
+                        </a:rPr>
+                        <a:t>Harsh</a:t>
+                      </a:r>
+                      <a:endParaRPr lang="en-IN" sz="2000" b="1" i="0" u="none" strike="noStrike">
+                        <a:solidFill>
+                          <a:srgbClr val="000000"/>
+                        </a:solidFill>
+                        <a:effectLst/>
+                        <a:latin typeface="Calibri" panose="020F0502020204030204" pitchFamily="34" charset="0"/>
+                      </a:endParaRPr>
+                    </a:p>
+                  </a:txBody>
+                  <a:tcPr marR="7620" marT="7620" marB="0" anchor="b"/>
+                </a:tc>
+                <a:tc>
+                  <a:txBody>
+                    <a:bodyPr/>
+                    <a:lstStyle/>
+                    <a:p>
+                      <a:pPr algn="l" fontAlgn="b"/>
+                      <a:r>
+                        <a:rPr lang="en-IN" sz="2000" b="1" u="none" strike="noStrike">
+                          <a:effectLst/>
+                        </a:rPr>
+                        <a:t>93</a:t>
+                      </a:r>
+                      <a:endParaRPr lang="en-IN" sz="2000" b="1" i="0" u="none" strike="noStrike">
+                        <a:solidFill>
+                          <a:srgbClr val="000000"/>
+                        </a:solidFill>
+                        <a:effectLst/>
+                        <a:latin typeface="Calibri" panose="020F0502020204030204" pitchFamily="34" charset="0"/>
+                      </a:endParaRPr>
+                    </a:p>
+                  </a:txBody>
+                  <a:tcPr marR="7620" marT="7620" marB="0" anchor="b"/>
+                </a:tc>
+                <a:tc>
+                  <a:txBody>
+                    <a:bodyPr/>
+                    <a:lstStyle/>
+                    <a:p>
+                      <a:pPr algn="l" fontAlgn="b"/>
+                      <a:r>
+                        <a:rPr lang="en-IN" sz="2000" b="1" u="none" strike="noStrike" dirty="0">
+                          <a:effectLst/>
+                        </a:rPr>
+                        <a:t>53</a:t>
+                      </a:r>
+                      <a:endParaRPr lang="en-IN" sz="2000" b="1" i="0" u="none" strike="noStrike" dirty="0">
+                        <a:solidFill>
+                          <a:srgbClr val="000000"/>
+                        </a:solidFill>
+                        <a:effectLst/>
+                        <a:latin typeface="Calibri" panose="020F0502020204030204" pitchFamily="34" charset="0"/>
+                      </a:endParaRPr>
+                    </a:p>
+                  </a:txBody>
+                  <a:tcPr marR="7620" marT="7620" marB="0" anchor="b"/>
+                </a:tc>
+                <a:tc>
+                  <a:txBody>
+                    <a:bodyPr/>
+                    <a:lstStyle/>
+                    <a:p>
+                      <a:pPr algn="l" fontAlgn="b"/>
+                      <a:r>
+                        <a:rPr lang="en-IN" sz="2000" b="1" u="none" strike="noStrike">
+                          <a:effectLst/>
+                        </a:rPr>
+                        <a:t>56</a:t>
+                      </a:r>
+                      <a:endParaRPr lang="en-IN" sz="2000" b="1" i="0" u="none" strike="noStrike">
+                        <a:solidFill>
+                          <a:srgbClr val="000000"/>
+                        </a:solidFill>
+                        <a:effectLst/>
+                        <a:latin typeface="Calibri" panose="020F0502020204030204" pitchFamily="34" charset="0"/>
+                      </a:endParaRPr>
+                    </a:p>
+                  </a:txBody>
+                  <a:tcPr marR="7620" marT="7620" marB="0" anchor="b"/>
+                </a:tc>
+                <a:tc>
+                  <a:txBody>
+                    <a:bodyPr/>
+                    <a:lstStyle/>
+                    <a:p>
+                      <a:pPr algn="l" fontAlgn="b"/>
+                      <a:endParaRPr lang="en-IN" sz="1800" b="1" i="0" u="none" strike="noStrike">
+                        <a:solidFill>
+                          <a:srgbClr val="000000"/>
+                        </a:solidFill>
+                        <a:effectLst/>
+                        <a:latin typeface="Calibri" panose="020F0502020204030204" pitchFamily="34" charset="0"/>
+                      </a:endParaRPr>
+                    </a:p>
+                  </a:txBody>
+                  <a:tcPr marL="7620" marR="7620" marT="7620" marB="0" anchor="b"/>
+                </a:tc>
+                <a:tc>
+                  <a:txBody>
+                    <a:bodyPr/>
+                    <a:lstStyle/>
+                    <a:p>
+                      <a:pPr algn="l" fontAlgn="b"/>
+                      <a:endParaRPr lang="en-IN" sz="1800" b="1" i="0" u="none" strike="noStrike">
+                        <a:solidFill>
+                          <a:srgbClr val="000000"/>
+                        </a:solidFill>
+                        <a:effectLst/>
+                        <a:latin typeface="Calibri" panose="020F0502020204030204" pitchFamily="34" charset="0"/>
+                      </a:endParaRPr>
+                    </a:p>
+                  </a:txBody>
+                  <a:tcPr marL="7620" marR="7620" marT="7620" marB="0" anchor="b"/>
+                </a:tc>
+                <a:tc>
+                  <a:txBody>
+                    <a:bodyPr/>
+                    <a:lstStyle/>
+                    <a:p>
+                      <a:pPr algn="l" fontAlgn="b"/>
+                      <a:endParaRPr lang="en-IN" sz="1800" b="1" i="0" u="none" strike="noStrike">
+                        <a:solidFill>
+                          <a:srgbClr val="000000"/>
+                        </a:solidFill>
+                        <a:effectLst/>
+                        <a:latin typeface="Calibri" panose="020F0502020204030204" pitchFamily="34" charset="0"/>
+                      </a:endParaRPr>
+                    </a:p>
+                  </a:txBody>
+                  <a:tcPr marL="7620" marR="7620" marT="7620" marB="0" anchor="b"/>
+                </a:tc>
+                <a:tc>
+                  <a:txBody>
+                    <a:bodyPr/>
+                    <a:lstStyle/>
+                    <a:p>
+                      <a:pPr algn="l" fontAlgn="b"/>
+                      <a:endParaRPr lang="en-IN" sz="1800" b="1" i="0" u="none" strike="noStrike">
+                        <a:solidFill>
+                          <a:srgbClr val="000000"/>
+                        </a:solidFill>
+                        <a:effectLst/>
+                        <a:latin typeface="Calibri" panose="020F0502020204030204" pitchFamily="34" charset="0"/>
+                      </a:endParaRPr>
+                    </a:p>
+                  </a:txBody>
+                  <a:tcPr marL="7620" marR="7620" marT="7620" marB="0" anchor="b"/>
+                </a:tc>
+                <a:tc>
+                  <a:txBody>
+                    <a:bodyPr/>
+                    <a:lstStyle/>
+                    <a:p>
+                      <a:pPr algn="l" fontAlgn="b"/>
+                      <a:endParaRPr lang="en-IN" sz="1800" b="1" i="0" u="none" strike="noStrike">
+                        <a:solidFill>
+                          <a:srgbClr val="000000"/>
+                        </a:solidFill>
+                        <a:effectLst/>
+                        <a:latin typeface="Calibri" panose="020F0502020204030204" pitchFamily="34" charset="0"/>
+                      </a:endParaRPr>
+                    </a:p>
+                  </a:txBody>
+                  <a:tcPr marL="7620" marR="7620" marT="7620" marB="0" anchor="b"/>
+                </a:tc>
+                <a:extLst>
+                  <a:ext uri="{0D108BD9-81ED-4DB2-BD59-A6C34878D82A}">
+                    <a16:rowId xmlns:a16="http://schemas.microsoft.com/office/drawing/2014/main" val="483570467"/>
+                  </a:ext>
+                </a:extLst>
+              </a:tr>
+              <a:tr h="423524">
+                <a:tc>
+                  <a:txBody>
+                    <a:bodyPr/>
+                    <a:lstStyle/>
+                    <a:p>
+                      <a:pPr algn="l" fontAlgn="b"/>
+                      <a:r>
+                        <a:rPr lang="en-IN" sz="2000" b="1" u="none" strike="noStrike">
+                          <a:effectLst/>
+                        </a:rPr>
+                        <a:t>John</a:t>
+                      </a:r>
+                      <a:endParaRPr lang="en-IN" sz="2000" b="1" i="0" u="none" strike="noStrike">
+                        <a:solidFill>
+                          <a:srgbClr val="000000"/>
+                        </a:solidFill>
+                        <a:effectLst/>
+                        <a:latin typeface="Calibri" panose="020F0502020204030204" pitchFamily="34" charset="0"/>
+                      </a:endParaRPr>
+                    </a:p>
+                  </a:txBody>
+                  <a:tcPr marR="7620" marT="7620" marB="0" anchor="b"/>
+                </a:tc>
+                <a:tc>
+                  <a:txBody>
+                    <a:bodyPr/>
+                    <a:lstStyle/>
+                    <a:p>
+                      <a:pPr algn="l" fontAlgn="b"/>
+                      <a:r>
+                        <a:rPr lang="en-IN" sz="2000" b="1" u="none" strike="noStrike">
+                          <a:effectLst/>
+                        </a:rPr>
+                        <a:t>86</a:t>
+                      </a:r>
+                      <a:endParaRPr lang="en-IN" sz="2000" b="1" i="0" u="none" strike="noStrike">
+                        <a:solidFill>
+                          <a:srgbClr val="000000"/>
+                        </a:solidFill>
+                        <a:effectLst/>
+                        <a:latin typeface="Calibri" panose="020F0502020204030204" pitchFamily="34" charset="0"/>
+                      </a:endParaRPr>
+                    </a:p>
+                  </a:txBody>
+                  <a:tcPr marR="7620" marT="7620" marB="0" anchor="b"/>
+                </a:tc>
+                <a:tc>
+                  <a:txBody>
+                    <a:bodyPr/>
+                    <a:lstStyle/>
+                    <a:p>
+                      <a:pPr algn="l" fontAlgn="b"/>
+                      <a:r>
+                        <a:rPr lang="en-IN" sz="2000" b="1" u="none" strike="noStrike">
+                          <a:effectLst/>
+                        </a:rPr>
+                        <a:t>34</a:t>
+                      </a:r>
+                      <a:endParaRPr lang="en-IN" sz="2000" b="1" i="0" u="none" strike="noStrike">
+                        <a:solidFill>
+                          <a:srgbClr val="000000"/>
+                        </a:solidFill>
+                        <a:effectLst/>
+                        <a:latin typeface="Calibri" panose="020F0502020204030204" pitchFamily="34" charset="0"/>
+                      </a:endParaRPr>
+                    </a:p>
+                  </a:txBody>
+                  <a:tcPr marR="7620" marT="7620" marB="0" anchor="b"/>
+                </a:tc>
+                <a:tc>
+                  <a:txBody>
+                    <a:bodyPr/>
+                    <a:lstStyle/>
+                    <a:p>
+                      <a:pPr algn="l" fontAlgn="b"/>
+                      <a:r>
+                        <a:rPr lang="en-IN" sz="2000" b="1" u="none" strike="noStrike">
+                          <a:effectLst/>
+                        </a:rPr>
+                        <a:t>80</a:t>
+                      </a:r>
+                      <a:endParaRPr lang="en-IN" sz="2000" b="1" i="0" u="none" strike="noStrike">
+                        <a:solidFill>
+                          <a:srgbClr val="000000"/>
+                        </a:solidFill>
+                        <a:effectLst/>
+                        <a:latin typeface="Calibri" panose="020F0502020204030204" pitchFamily="34" charset="0"/>
+                      </a:endParaRPr>
+                    </a:p>
+                  </a:txBody>
+                  <a:tcPr marR="7620" marT="7620" marB="0" anchor="b"/>
+                </a:tc>
+                <a:tc>
+                  <a:txBody>
+                    <a:bodyPr/>
+                    <a:lstStyle/>
+                    <a:p>
+                      <a:pPr algn="l" fontAlgn="b"/>
+                      <a:endParaRPr lang="en-IN" sz="1800" b="1" i="0" u="none" strike="noStrike" dirty="0">
+                        <a:solidFill>
+                          <a:srgbClr val="000000"/>
+                        </a:solidFill>
+                        <a:effectLst/>
+                        <a:latin typeface="Calibri" panose="020F0502020204030204" pitchFamily="34" charset="0"/>
+                      </a:endParaRPr>
+                    </a:p>
+                  </a:txBody>
+                  <a:tcPr marL="7620" marR="7620" marT="7620" marB="0" anchor="b"/>
+                </a:tc>
+                <a:tc>
+                  <a:txBody>
+                    <a:bodyPr/>
+                    <a:lstStyle/>
+                    <a:p>
+                      <a:pPr algn="l" fontAlgn="b"/>
+                      <a:endParaRPr lang="en-IN" sz="1800" b="1" i="0" u="none" strike="noStrike">
+                        <a:solidFill>
+                          <a:srgbClr val="000000"/>
+                        </a:solidFill>
+                        <a:effectLst/>
+                        <a:latin typeface="Calibri" panose="020F0502020204030204" pitchFamily="34" charset="0"/>
+                      </a:endParaRPr>
+                    </a:p>
+                  </a:txBody>
+                  <a:tcPr marL="7620" marR="7620" marT="7620" marB="0" anchor="b"/>
+                </a:tc>
+                <a:tc>
+                  <a:txBody>
+                    <a:bodyPr/>
+                    <a:lstStyle/>
+                    <a:p>
+                      <a:pPr algn="l" fontAlgn="b"/>
+                      <a:endParaRPr lang="en-IN" sz="1800" b="1" i="0" u="none" strike="noStrike">
+                        <a:solidFill>
+                          <a:srgbClr val="000000"/>
+                        </a:solidFill>
+                        <a:effectLst/>
+                        <a:latin typeface="Calibri" panose="020F0502020204030204" pitchFamily="34" charset="0"/>
+                      </a:endParaRPr>
+                    </a:p>
+                  </a:txBody>
+                  <a:tcPr marL="7620" marR="7620" marT="7620" marB="0" anchor="b"/>
+                </a:tc>
+                <a:tc>
+                  <a:txBody>
+                    <a:bodyPr/>
+                    <a:lstStyle/>
+                    <a:p>
+                      <a:pPr algn="l" fontAlgn="b"/>
+                      <a:endParaRPr lang="en-IN" sz="1800" b="1" i="0" u="none" strike="noStrike">
+                        <a:solidFill>
+                          <a:srgbClr val="000000"/>
+                        </a:solidFill>
+                        <a:effectLst/>
+                        <a:latin typeface="Calibri" panose="020F0502020204030204" pitchFamily="34" charset="0"/>
+                      </a:endParaRPr>
+                    </a:p>
+                  </a:txBody>
+                  <a:tcPr marL="7620" marR="7620" marT="7620" marB="0" anchor="b"/>
+                </a:tc>
+                <a:tc>
+                  <a:txBody>
+                    <a:bodyPr/>
+                    <a:lstStyle/>
+                    <a:p>
+                      <a:pPr algn="l" fontAlgn="b"/>
+                      <a:endParaRPr lang="en-IN" sz="1800" b="1" i="0" u="none" strike="noStrike">
+                        <a:solidFill>
+                          <a:srgbClr val="000000"/>
+                        </a:solidFill>
+                        <a:effectLst/>
+                        <a:latin typeface="Calibri" panose="020F0502020204030204" pitchFamily="34" charset="0"/>
+                      </a:endParaRPr>
+                    </a:p>
+                  </a:txBody>
+                  <a:tcPr marL="7620" marR="7620" marT="7620" marB="0" anchor="b"/>
+                </a:tc>
+                <a:extLst>
+                  <a:ext uri="{0D108BD9-81ED-4DB2-BD59-A6C34878D82A}">
+                    <a16:rowId xmlns:a16="http://schemas.microsoft.com/office/drawing/2014/main" val="3858827223"/>
+                  </a:ext>
+                </a:extLst>
+              </a:tr>
+              <a:tr h="423524">
+                <a:tc>
+                  <a:txBody>
+                    <a:bodyPr/>
+                    <a:lstStyle/>
+                    <a:p>
+                      <a:pPr algn="l" fontAlgn="b"/>
+                      <a:r>
+                        <a:rPr lang="en-IN" sz="2000" b="1" u="none" strike="noStrike">
+                          <a:effectLst/>
+                        </a:rPr>
+                        <a:t>Mahesh</a:t>
+                      </a:r>
+                      <a:endParaRPr lang="en-IN" sz="2000" b="1" i="0" u="none" strike="noStrike">
+                        <a:solidFill>
+                          <a:srgbClr val="000000"/>
+                        </a:solidFill>
+                        <a:effectLst/>
+                        <a:latin typeface="Calibri" panose="020F0502020204030204" pitchFamily="34" charset="0"/>
+                      </a:endParaRPr>
+                    </a:p>
+                  </a:txBody>
+                  <a:tcPr marR="7620" marT="7620" marB="0" anchor="b"/>
+                </a:tc>
+                <a:tc>
+                  <a:txBody>
+                    <a:bodyPr/>
+                    <a:lstStyle/>
+                    <a:p>
+                      <a:pPr algn="l" fontAlgn="b"/>
+                      <a:r>
+                        <a:rPr lang="en-IN" sz="2000" b="1" u="none" strike="noStrike">
+                          <a:effectLst/>
+                        </a:rPr>
+                        <a:t>38</a:t>
+                      </a:r>
+                      <a:endParaRPr lang="en-IN" sz="2000" b="1" i="0" u="none" strike="noStrike">
+                        <a:solidFill>
+                          <a:srgbClr val="000000"/>
+                        </a:solidFill>
+                        <a:effectLst/>
+                        <a:latin typeface="Calibri" panose="020F0502020204030204" pitchFamily="34" charset="0"/>
+                      </a:endParaRPr>
+                    </a:p>
+                  </a:txBody>
+                  <a:tcPr marR="7620" marT="7620" marB="0" anchor="b"/>
+                </a:tc>
+                <a:tc>
+                  <a:txBody>
+                    <a:bodyPr/>
+                    <a:lstStyle/>
+                    <a:p>
+                      <a:pPr algn="l" fontAlgn="b"/>
+                      <a:r>
+                        <a:rPr lang="en-IN" sz="2000" b="1" u="none" strike="noStrike">
+                          <a:effectLst/>
+                        </a:rPr>
+                        <a:t>39</a:t>
+                      </a:r>
+                      <a:endParaRPr lang="en-IN" sz="2000" b="1" i="0" u="none" strike="noStrike">
+                        <a:solidFill>
+                          <a:srgbClr val="000000"/>
+                        </a:solidFill>
+                        <a:effectLst/>
+                        <a:latin typeface="Calibri" panose="020F0502020204030204" pitchFamily="34" charset="0"/>
+                      </a:endParaRPr>
+                    </a:p>
+                  </a:txBody>
+                  <a:tcPr marR="7620" marT="7620" marB="0" anchor="b"/>
+                </a:tc>
+                <a:tc>
+                  <a:txBody>
+                    <a:bodyPr/>
+                    <a:lstStyle/>
+                    <a:p>
+                      <a:pPr algn="l" fontAlgn="b"/>
+                      <a:r>
+                        <a:rPr lang="en-IN" sz="2000" b="1" u="none" strike="noStrike">
+                          <a:effectLst/>
+                        </a:rPr>
+                        <a:t>51</a:t>
+                      </a:r>
+                      <a:endParaRPr lang="en-IN" sz="2000" b="1" i="0" u="none" strike="noStrike">
+                        <a:solidFill>
+                          <a:srgbClr val="000000"/>
+                        </a:solidFill>
+                        <a:effectLst/>
+                        <a:latin typeface="Calibri" panose="020F0502020204030204" pitchFamily="34" charset="0"/>
+                      </a:endParaRPr>
+                    </a:p>
+                  </a:txBody>
+                  <a:tcPr marR="7620" marT="7620" marB="0" anchor="b"/>
+                </a:tc>
+                <a:tc>
+                  <a:txBody>
+                    <a:bodyPr/>
+                    <a:lstStyle/>
+                    <a:p>
+                      <a:pPr algn="l" fontAlgn="b"/>
+                      <a:endParaRPr lang="en-IN" sz="1800" b="1" i="0" u="none" strike="noStrike">
+                        <a:solidFill>
+                          <a:srgbClr val="000000"/>
+                        </a:solidFill>
+                        <a:effectLst/>
+                        <a:latin typeface="Calibri" panose="020F0502020204030204" pitchFamily="34" charset="0"/>
+                      </a:endParaRPr>
+                    </a:p>
+                  </a:txBody>
+                  <a:tcPr marL="7620" marR="7620" marT="7620" marB="0" anchor="b"/>
+                </a:tc>
+                <a:tc>
+                  <a:txBody>
+                    <a:bodyPr/>
+                    <a:lstStyle/>
+                    <a:p>
+                      <a:pPr algn="l" fontAlgn="b"/>
+                      <a:endParaRPr lang="en-IN" sz="1800" b="1" i="0" u="none" strike="noStrike">
+                        <a:solidFill>
+                          <a:srgbClr val="000000"/>
+                        </a:solidFill>
+                        <a:effectLst/>
+                        <a:latin typeface="Calibri" panose="020F0502020204030204" pitchFamily="34" charset="0"/>
+                      </a:endParaRPr>
+                    </a:p>
+                  </a:txBody>
+                  <a:tcPr marL="7620" marR="7620" marT="7620" marB="0" anchor="b"/>
+                </a:tc>
+                <a:tc>
+                  <a:txBody>
+                    <a:bodyPr/>
+                    <a:lstStyle/>
+                    <a:p>
+                      <a:pPr algn="l" fontAlgn="b"/>
+                      <a:endParaRPr lang="en-IN" sz="1800" b="1" i="0" u="none" strike="noStrike">
+                        <a:solidFill>
+                          <a:srgbClr val="000000"/>
+                        </a:solidFill>
+                        <a:effectLst/>
+                        <a:latin typeface="Calibri" panose="020F0502020204030204" pitchFamily="34" charset="0"/>
+                      </a:endParaRPr>
+                    </a:p>
+                  </a:txBody>
+                  <a:tcPr marL="7620" marR="7620" marT="7620" marB="0" anchor="b"/>
+                </a:tc>
+                <a:tc>
+                  <a:txBody>
+                    <a:bodyPr/>
+                    <a:lstStyle/>
+                    <a:p>
+                      <a:pPr algn="l" fontAlgn="b"/>
+                      <a:endParaRPr lang="en-IN" sz="1800" b="1" i="0" u="none" strike="noStrike">
+                        <a:solidFill>
+                          <a:srgbClr val="000000"/>
+                        </a:solidFill>
+                        <a:effectLst/>
+                        <a:latin typeface="Calibri" panose="020F0502020204030204" pitchFamily="34" charset="0"/>
+                      </a:endParaRPr>
+                    </a:p>
+                  </a:txBody>
+                  <a:tcPr marL="7620" marR="7620" marT="7620" marB="0" anchor="b"/>
+                </a:tc>
+                <a:tc>
+                  <a:txBody>
+                    <a:bodyPr/>
+                    <a:lstStyle/>
+                    <a:p>
+                      <a:pPr algn="l" fontAlgn="b"/>
+                      <a:endParaRPr lang="en-IN" sz="1800" b="1" i="0" u="none" strike="noStrike" dirty="0">
+                        <a:solidFill>
+                          <a:srgbClr val="000000"/>
+                        </a:solidFill>
+                        <a:effectLst/>
+                        <a:latin typeface="Calibri" panose="020F0502020204030204" pitchFamily="34" charset="0"/>
+                      </a:endParaRPr>
+                    </a:p>
+                  </a:txBody>
+                  <a:tcPr marL="7620" marR="7620" marT="7620" marB="0" anchor="b"/>
+                </a:tc>
+                <a:extLst>
+                  <a:ext uri="{0D108BD9-81ED-4DB2-BD59-A6C34878D82A}">
+                    <a16:rowId xmlns:a16="http://schemas.microsoft.com/office/drawing/2014/main" val="3088557193"/>
+                  </a:ext>
+                </a:extLst>
+              </a:tr>
+            </a:tbl>
+          </a:graphicData>
+        </a:graphic>
+      </p:graphicFrame>
     </p:spTree>
     <p:extLst>
       <p:ext uri="{BB962C8B-B14F-4D97-AF65-F5344CB8AC3E}">
-        <p14:creationId xmlns:p14="http://schemas.microsoft.com/office/powerpoint/2010/main" val="4115638078"/>
+        <p14:creationId xmlns:p14="http://schemas.microsoft.com/office/powerpoint/2010/main" val="158702206"/>
       </p:ext>
     </p:extLst>
   </p:cSld>
@@ -6157,48 +6987,12 @@
           <a:chExt cx="0" cy="0"/>
         </a:xfrm>
       </p:grpSpPr>
-      <p:pic>
-        <p:nvPicPr>
-          <p:cNvPr id="7" name="Picture 6">
+      <p:sp>
+        <p:nvSpPr>
+          <p:cNvPr id="2" name="Oval 1">
             <a:extLst>
               <a:ext uri="{FF2B5EF4-FFF2-40B4-BE49-F238E27FC236}">
-                <a16:creationId xmlns:a16="http://schemas.microsoft.com/office/drawing/2014/main" id="{46525F87-7270-4174-9EC6-D95F6D145A50}"/>
-              </a:ext>
-            </a:extLst>
-          </p:cNvPr>
-          <p:cNvPicPr>
-            <a:picLocks noChangeAspect="1"/>
-          </p:cNvPicPr>
-          <p:nvPr/>
-        </p:nvPicPr>
-        <p:blipFill>
-          <a:blip r:embed="rId2">
-            <a:extLst>
-              <a:ext uri="{28A0092B-C50C-407E-A947-70E740481C1C}">
-                <a14:useLocalDpi xmlns:a14="http://schemas.microsoft.com/office/drawing/2010/main" val="0"/>
-              </a:ext>
-            </a:extLst>
-          </a:blip>
-          <a:stretch>
-            <a:fillRect/>
-          </a:stretch>
-        </p:blipFill>
-        <p:spPr>
-          <a:xfrm>
-            <a:off x="5956077" y="0"/>
-            <a:ext cx="6235924" cy="6858000"/>
-          </a:xfrm>
-          <a:prstGeom prst="rect">
-            <a:avLst/>
-          </a:prstGeom>
-        </p:spPr>
-      </p:pic>
-      <p:sp>
-        <p:nvSpPr>
-          <p:cNvPr id="8" name="Oval 7">
-            <a:extLst>
-              <a:ext uri="{FF2B5EF4-FFF2-40B4-BE49-F238E27FC236}">
-                <a16:creationId xmlns:a16="http://schemas.microsoft.com/office/drawing/2014/main" id="{DD19CF32-87B5-402D-8EA7-7E9BA1060AE0}"/>
+                <a16:creationId xmlns:a16="http://schemas.microsoft.com/office/drawing/2014/main" id="{14817208-43A0-4277-ACFA-AFE30CEF256B}"/>
               </a:ext>
             </a:extLst>
           </p:cNvPr>
@@ -6207,7 +7001,7 @@
         </p:nvSpPr>
         <p:spPr>
           <a:xfrm>
-            <a:off x="1064870" y="1705819"/>
+            <a:off x="509285" y="1798416"/>
             <a:ext cx="3472405" cy="3446362"/>
           </a:xfrm>
           <a:prstGeom prst="ellipse">
@@ -6255,7 +7049,7 @@
                   <a:srgbClr val="FF0000"/>
                 </a:solidFill>
               </a:rPr>
-              <a:t>Task 2 : Create A Resume</a:t>
+              <a:t>Task 2 : Create A Chart</a:t>
             </a:r>
             <a:endParaRPr lang="en-IN" sz="2400" b="1" dirty="0">
               <a:solidFill>
@@ -6265,10 +7059,54 @@
           </a:p>
         </p:txBody>
       </p:sp>
+      <p:sp>
+        <p:nvSpPr>
+          <p:cNvPr id="3" name="TextBox 2">
+            <a:extLst>
+              <a:ext uri="{FF2B5EF4-FFF2-40B4-BE49-F238E27FC236}">
+                <a16:creationId xmlns:a16="http://schemas.microsoft.com/office/drawing/2014/main" id="{2D451D4B-3F79-4337-9094-08FA9F8A230B}"/>
+              </a:ext>
+            </a:extLst>
+          </p:cNvPr>
+          <p:cNvSpPr txBox="1"/>
+          <p:nvPr/>
+        </p:nvSpPr>
+        <p:spPr>
+          <a:xfrm>
+            <a:off x="4299995" y="2753032"/>
+            <a:ext cx="7715024" cy="830997"/>
+          </a:xfrm>
+          <a:prstGeom prst="rect">
+            <a:avLst/>
+          </a:prstGeom>
+          <a:noFill/>
+        </p:spPr>
+        <p:txBody>
+          <a:bodyPr wrap="square" rtlCol="0">
+            <a:spAutoFit/>
+          </a:bodyPr>
+          <a:lstStyle/>
+          <a:p>
+            <a:r>
+              <a:rPr lang="en-US" sz="2400" b="1" dirty="0"/>
+              <a:t>Generate Random data using </a:t>
+            </a:r>
+            <a:r>
+              <a:rPr lang="en-US" sz="2400" b="1" dirty="0" err="1"/>
+              <a:t>RandomBetween</a:t>
+            </a:r>
+            <a:r>
+              <a:rPr lang="en-US" sz="2400" b="1" dirty="0"/>
+              <a:t> Formula and Apply Conditional Formatting</a:t>
+            </a:r>
+            <a:endParaRPr lang="en-IN" sz="2400" b="1" dirty="0"/>
+          </a:p>
+        </p:txBody>
+      </p:sp>
     </p:spTree>
     <p:extLst>
       <p:ext uri="{BB962C8B-B14F-4D97-AF65-F5344CB8AC3E}">
-        <p14:creationId xmlns:p14="http://schemas.microsoft.com/office/powerpoint/2010/main" val="59337256"/>
+        <p14:creationId xmlns:p14="http://schemas.microsoft.com/office/powerpoint/2010/main" val="4079808065"/>
       </p:ext>
     </p:extLst>
   </p:cSld>
@@ -6297,10 +7135,10 @@
       </p:grpSpPr>
       <p:sp>
         <p:nvSpPr>
-          <p:cNvPr id="2" name="Oval 1">
+          <p:cNvPr id="8" name="Oval 7">
             <a:extLst>
               <a:ext uri="{FF2B5EF4-FFF2-40B4-BE49-F238E27FC236}">
-                <a16:creationId xmlns:a16="http://schemas.microsoft.com/office/drawing/2014/main" id="{14817208-43A0-4277-ACFA-AFE30CEF256B}"/>
+                <a16:creationId xmlns:a16="http://schemas.microsoft.com/office/drawing/2014/main" id="{DD19CF32-87B5-402D-8EA7-7E9BA1060AE0}"/>
               </a:ext>
             </a:extLst>
           </p:cNvPr>
@@ -6309,7 +7147,7 @@
         </p:nvSpPr>
         <p:spPr>
           <a:xfrm>
-            <a:off x="509285" y="1798416"/>
+            <a:off x="1064870" y="1705819"/>
             <a:ext cx="3472405" cy="3446362"/>
           </a:xfrm>
           <a:prstGeom prst="ellipse">
@@ -6357,7 +7195,7 @@
                   <a:srgbClr val="FF0000"/>
                 </a:solidFill>
               </a:rPr>
-              <a:t>Task 3 : Create A Hierarchy</a:t>
+              <a:t>Task 3 : Prepare Chart For Data</a:t>
             </a:r>
             <a:endParaRPr lang="en-IN" sz="2400" b="1" dirty="0">
               <a:solidFill>
@@ -6367,46 +7205,738 @@
           </a:p>
         </p:txBody>
       </p:sp>
-      <p:pic>
-        <p:nvPicPr>
-          <p:cNvPr id="4" name="Picture 3">
+      <p:graphicFrame>
+        <p:nvGraphicFramePr>
+          <p:cNvPr id="2" name="Table 1">
             <a:extLst>
               <a:ext uri="{FF2B5EF4-FFF2-40B4-BE49-F238E27FC236}">
-                <a16:creationId xmlns:a16="http://schemas.microsoft.com/office/drawing/2014/main" id="{B1698C17-3F66-4322-AF30-44D3ED934F9C}"/>
+                <a16:creationId xmlns:a16="http://schemas.microsoft.com/office/drawing/2014/main" id="{CEE52740-205B-4110-9CA2-7D085AECB8AD}"/>
               </a:ext>
             </a:extLst>
           </p:cNvPr>
-          <p:cNvPicPr>
-            <a:picLocks noChangeAspect="1"/>
-          </p:cNvPicPr>
-          <p:nvPr/>
-        </p:nvPicPr>
-        <p:blipFill>
-          <a:blip r:embed="rId2">
-            <a:extLst>
-              <a:ext uri="{28A0092B-C50C-407E-A947-70E740481C1C}">
-                <a14:useLocalDpi xmlns:a14="http://schemas.microsoft.com/office/drawing/2010/main" val="0"/>
-              </a:ext>
-            </a:extLst>
-          </a:blip>
-          <a:stretch>
-            <a:fillRect/>
-          </a:stretch>
-        </p:blipFill>
-        <p:spPr>
-          <a:xfrm>
-            <a:off x="4271832" y="1076446"/>
-            <a:ext cx="7520328" cy="4479402"/>
-          </a:xfrm>
-          <a:prstGeom prst="roundRect">
-            <a:avLst/>
-          </a:prstGeom>
-        </p:spPr>
-      </p:pic>
+          <p:cNvGraphicFramePr>
+            <a:graphicFrameLocks noGrp="1"/>
+          </p:cNvGraphicFramePr>
+          <p:nvPr>
+            <p:extLst>
+              <p:ext uri="{D42A27DB-BD31-4B8C-83A1-F6EECF244321}">
+                <p14:modId xmlns:p14="http://schemas.microsoft.com/office/powerpoint/2010/main" val="47252908"/>
+              </p:ext>
+            </p:extLst>
+          </p:nvPr>
+        </p:nvGraphicFramePr>
+        <p:xfrm>
+          <a:off x="4874499" y="2331720"/>
+          <a:ext cx="5560455" cy="2377440"/>
+        </p:xfrm>
+        <a:graphic>
+          <a:graphicData uri="http://schemas.openxmlformats.org/drawingml/2006/table">
+            <a:tbl>
+              <a:tblPr/>
+              <a:tblGrid>
+                <a:gridCol w="2040506">
+                  <a:extLst>
+                    <a:ext uri="{9D8B030D-6E8A-4147-A177-3AD203B41FA5}">
+                      <a16:colId xmlns:a16="http://schemas.microsoft.com/office/drawing/2014/main" val="2644838269"/>
+                    </a:ext>
+                  </a:extLst>
+                </a:gridCol>
+                <a:gridCol w="963561">
+                  <a:extLst>
+                    <a:ext uri="{9D8B030D-6E8A-4147-A177-3AD203B41FA5}">
+                      <a16:colId xmlns:a16="http://schemas.microsoft.com/office/drawing/2014/main" val="2996437503"/>
+                    </a:ext>
+                  </a:extLst>
+                </a:gridCol>
+                <a:gridCol w="1235937">
+                  <a:extLst>
+                    <a:ext uri="{9D8B030D-6E8A-4147-A177-3AD203B41FA5}">
+                      <a16:colId xmlns:a16="http://schemas.microsoft.com/office/drawing/2014/main" val="618490265"/>
+                    </a:ext>
+                  </a:extLst>
+                </a:gridCol>
+                <a:gridCol w="1320451">
+                  <a:extLst>
+                    <a:ext uri="{9D8B030D-6E8A-4147-A177-3AD203B41FA5}">
+                      <a16:colId xmlns:a16="http://schemas.microsoft.com/office/drawing/2014/main" val="3777460904"/>
+                    </a:ext>
+                  </a:extLst>
+                </a:gridCol>
+              </a:tblGrid>
+              <a:tr h="0">
+                <a:tc>
+                  <a:txBody>
+                    <a:bodyPr/>
+                    <a:lstStyle/>
+                    <a:p>
+                      <a:r>
+                        <a:rPr lang="en-IN" sz="2000" b="1" dirty="0"/>
+                        <a:t>Student Name</a:t>
+                      </a:r>
+                    </a:p>
+                  </a:txBody>
+                  <a:tcPr anchor="ctr">
+                    <a:lnL>
+                      <a:noFill/>
+                    </a:lnL>
+                    <a:lnR>
+                      <a:noFill/>
+                    </a:lnR>
+                    <a:lnT>
+                      <a:noFill/>
+                    </a:lnT>
+                    <a:lnB>
+                      <a:noFill/>
+                    </a:lnB>
+                  </a:tcPr>
+                </a:tc>
+                <a:tc>
+                  <a:txBody>
+                    <a:bodyPr/>
+                    <a:lstStyle/>
+                    <a:p>
+                      <a:r>
+                        <a:rPr lang="en-IN" sz="2000" b="1"/>
+                        <a:t>Maths</a:t>
+                      </a:r>
+                    </a:p>
+                  </a:txBody>
+                  <a:tcPr anchor="ctr">
+                    <a:lnL>
+                      <a:noFill/>
+                    </a:lnL>
+                    <a:lnR>
+                      <a:noFill/>
+                    </a:lnR>
+                    <a:lnT>
+                      <a:noFill/>
+                    </a:lnT>
+                    <a:lnB>
+                      <a:noFill/>
+                    </a:lnB>
+                  </a:tcPr>
+                </a:tc>
+                <a:tc>
+                  <a:txBody>
+                    <a:bodyPr/>
+                    <a:lstStyle/>
+                    <a:p>
+                      <a:r>
+                        <a:rPr lang="en-IN" sz="2000" b="1"/>
+                        <a:t>Science</a:t>
+                      </a:r>
+                    </a:p>
+                  </a:txBody>
+                  <a:tcPr anchor="ctr">
+                    <a:lnL>
+                      <a:noFill/>
+                    </a:lnL>
+                    <a:lnR>
+                      <a:noFill/>
+                    </a:lnR>
+                    <a:lnT>
+                      <a:noFill/>
+                    </a:lnT>
+                    <a:lnB>
+                      <a:noFill/>
+                    </a:lnB>
+                  </a:tcPr>
+                </a:tc>
+                <a:tc>
+                  <a:txBody>
+                    <a:bodyPr/>
+                    <a:lstStyle/>
+                    <a:p>
+                      <a:r>
+                        <a:rPr lang="en-IN" sz="2000" b="1"/>
+                        <a:t>English</a:t>
+                      </a:r>
+                    </a:p>
+                  </a:txBody>
+                  <a:tcPr anchor="ctr">
+                    <a:lnL>
+                      <a:noFill/>
+                    </a:lnL>
+                    <a:lnR>
+                      <a:noFill/>
+                    </a:lnR>
+                    <a:lnT>
+                      <a:noFill/>
+                    </a:lnT>
+                    <a:lnB>
+                      <a:noFill/>
+                    </a:lnB>
+                  </a:tcPr>
+                </a:tc>
+                <a:extLst>
+                  <a:ext uri="{0D108BD9-81ED-4DB2-BD59-A6C34878D82A}">
+                    <a16:rowId xmlns:a16="http://schemas.microsoft.com/office/drawing/2014/main" val="1036372672"/>
+                  </a:ext>
+                </a:extLst>
+              </a:tr>
+              <a:tr h="0">
+                <a:tc>
+                  <a:txBody>
+                    <a:bodyPr/>
+                    <a:lstStyle/>
+                    <a:p>
+                      <a:r>
+                        <a:rPr lang="en-IN" sz="2000" b="1" dirty="0"/>
+                        <a:t>Amit</a:t>
+                      </a:r>
+                    </a:p>
+                  </a:txBody>
+                  <a:tcPr anchor="ctr">
+                    <a:lnL>
+                      <a:noFill/>
+                    </a:lnL>
+                    <a:lnR>
+                      <a:noFill/>
+                    </a:lnR>
+                    <a:lnT>
+                      <a:noFill/>
+                    </a:lnT>
+                    <a:lnB>
+                      <a:noFill/>
+                    </a:lnB>
+                  </a:tcPr>
+                </a:tc>
+                <a:tc>
+                  <a:txBody>
+                    <a:bodyPr/>
+                    <a:lstStyle/>
+                    <a:p>
+                      <a:r>
+                        <a:rPr lang="en-IN" sz="2000" b="1" dirty="0"/>
+                        <a:t>78</a:t>
+                      </a:r>
+                    </a:p>
+                  </a:txBody>
+                  <a:tcPr anchor="ctr">
+                    <a:lnL>
+                      <a:noFill/>
+                    </a:lnL>
+                    <a:lnR>
+                      <a:noFill/>
+                    </a:lnR>
+                    <a:lnT>
+                      <a:noFill/>
+                    </a:lnT>
+                    <a:lnB>
+                      <a:noFill/>
+                    </a:lnB>
+                  </a:tcPr>
+                </a:tc>
+                <a:tc>
+                  <a:txBody>
+                    <a:bodyPr/>
+                    <a:lstStyle/>
+                    <a:p>
+                      <a:r>
+                        <a:rPr lang="en-IN" sz="2000" b="1"/>
+                        <a:t>85</a:t>
+                      </a:r>
+                    </a:p>
+                  </a:txBody>
+                  <a:tcPr anchor="ctr">
+                    <a:lnL>
+                      <a:noFill/>
+                    </a:lnL>
+                    <a:lnR>
+                      <a:noFill/>
+                    </a:lnR>
+                    <a:lnT>
+                      <a:noFill/>
+                    </a:lnT>
+                    <a:lnB>
+                      <a:noFill/>
+                    </a:lnB>
+                  </a:tcPr>
+                </a:tc>
+                <a:tc>
+                  <a:txBody>
+                    <a:bodyPr/>
+                    <a:lstStyle/>
+                    <a:p>
+                      <a:r>
+                        <a:rPr lang="en-IN" sz="2000" b="1"/>
+                        <a:t>80</a:t>
+                      </a:r>
+                    </a:p>
+                  </a:txBody>
+                  <a:tcPr anchor="ctr">
+                    <a:lnL>
+                      <a:noFill/>
+                    </a:lnL>
+                    <a:lnR>
+                      <a:noFill/>
+                    </a:lnR>
+                    <a:lnT>
+                      <a:noFill/>
+                    </a:lnT>
+                    <a:lnB>
+                      <a:noFill/>
+                    </a:lnB>
+                  </a:tcPr>
+                </a:tc>
+                <a:extLst>
+                  <a:ext uri="{0D108BD9-81ED-4DB2-BD59-A6C34878D82A}">
+                    <a16:rowId xmlns:a16="http://schemas.microsoft.com/office/drawing/2014/main" val="1030807196"/>
+                  </a:ext>
+                </a:extLst>
+              </a:tr>
+              <a:tr h="0">
+                <a:tc>
+                  <a:txBody>
+                    <a:bodyPr/>
+                    <a:lstStyle/>
+                    <a:p>
+                      <a:r>
+                        <a:rPr lang="en-IN" sz="2000" b="1"/>
+                        <a:t>Neha</a:t>
+                      </a:r>
+                    </a:p>
+                  </a:txBody>
+                  <a:tcPr anchor="ctr">
+                    <a:lnL>
+                      <a:noFill/>
+                    </a:lnL>
+                    <a:lnR>
+                      <a:noFill/>
+                    </a:lnR>
+                    <a:lnT>
+                      <a:noFill/>
+                    </a:lnT>
+                    <a:lnB>
+                      <a:noFill/>
+                    </a:lnB>
+                  </a:tcPr>
+                </a:tc>
+                <a:tc>
+                  <a:txBody>
+                    <a:bodyPr/>
+                    <a:lstStyle/>
+                    <a:p>
+                      <a:r>
+                        <a:rPr lang="en-IN" sz="2000" b="1"/>
+                        <a:t>88</a:t>
+                      </a:r>
+                    </a:p>
+                  </a:txBody>
+                  <a:tcPr anchor="ctr">
+                    <a:lnL>
+                      <a:noFill/>
+                    </a:lnL>
+                    <a:lnR>
+                      <a:noFill/>
+                    </a:lnR>
+                    <a:lnT>
+                      <a:noFill/>
+                    </a:lnT>
+                    <a:lnB>
+                      <a:noFill/>
+                    </a:lnB>
+                  </a:tcPr>
+                </a:tc>
+                <a:tc>
+                  <a:txBody>
+                    <a:bodyPr/>
+                    <a:lstStyle/>
+                    <a:p>
+                      <a:r>
+                        <a:rPr lang="en-IN" sz="2000" b="1" dirty="0"/>
+                        <a:t>79</a:t>
+                      </a:r>
+                    </a:p>
+                  </a:txBody>
+                  <a:tcPr anchor="ctr">
+                    <a:lnL>
+                      <a:noFill/>
+                    </a:lnL>
+                    <a:lnR>
+                      <a:noFill/>
+                    </a:lnR>
+                    <a:lnT>
+                      <a:noFill/>
+                    </a:lnT>
+                    <a:lnB>
+                      <a:noFill/>
+                    </a:lnB>
+                  </a:tcPr>
+                </a:tc>
+                <a:tc>
+                  <a:txBody>
+                    <a:bodyPr/>
+                    <a:lstStyle/>
+                    <a:p>
+                      <a:r>
+                        <a:rPr lang="en-IN" sz="2000" b="1"/>
+                        <a:t>90</a:t>
+                      </a:r>
+                    </a:p>
+                  </a:txBody>
+                  <a:tcPr anchor="ctr">
+                    <a:lnL>
+                      <a:noFill/>
+                    </a:lnL>
+                    <a:lnR>
+                      <a:noFill/>
+                    </a:lnR>
+                    <a:lnT>
+                      <a:noFill/>
+                    </a:lnT>
+                    <a:lnB>
+                      <a:noFill/>
+                    </a:lnB>
+                  </a:tcPr>
+                </a:tc>
+                <a:extLst>
+                  <a:ext uri="{0D108BD9-81ED-4DB2-BD59-A6C34878D82A}">
+                    <a16:rowId xmlns:a16="http://schemas.microsoft.com/office/drawing/2014/main" val="1368900605"/>
+                  </a:ext>
+                </a:extLst>
+              </a:tr>
+              <a:tr h="0">
+                <a:tc>
+                  <a:txBody>
+                    <a:bodyPr/>
+                    <a:lstStyle/>
+                    <a:p>
+                      <a:r>
+                        <a:rPr lang="en-IN" sz="2000" b="1"/>
+                        <a:t>Rahul</a:t>
+                      </a:r>
+                    </a:p>
+                  </a:txBody>
+                  <a:tcPr anchor="ctr">
+                    <a:lnL>
+                      <a:noFill/>
+                    </a:lnL>
+                    <a:lnR>
+                      <a:noFill/>
+                    </a:lnR>
+                    <a:lnT>
+                      <a:noFill/>
+                    </a:lnT>
+                    <a:lnB>
+                      <a:noFill/>
+                    </a:lnB>
+                  </a:tcPr>
+                </a:tc>
+                <a:tc>
+                  <a:txBody>
+                    <a:bodyPr/>
+                    <a:lstStyle/>
+                    <a:p>
+                      <a:r>
+                        <a:rPr lang="en-IN" sz="2000" b="1"/>
+                        <a:t>65</a:t>
+                      </a:r>
+                    </a:p>
+                  </a:txBody>
+                  <a:tcPr anchor="ctr">
+                    <a:lnL>
+                      <a:noFill/>
+                    </a:lnL>
+                    <a:lnR>
+                      <a:noFill/>
+                    </a:lnR>
+                    <a:lnT>
+                      <a:noFill/>
+                    </a:lnT>
+                    <a:lnB>
+                      <a:noFill/>
+                    </a:lnB>
+                  </a:tcPr>
+                </a:tc>
+                <a:tc>
+                  <a:txBody>
+                    <a:bodyPr/>
+                    <a:lstStyle/>
+                    <a:p>
+                      <a:r>
+                        <a:rPr lang="en-IN" sz="2000" b="1"/>
+                        <a:t>70</a:t>
+                      </a:r>
+                    </a:p>
+                  </a:txBody>
+                  <a:tcPr anchor="ctr">
+                    <a:lnL>
+                      <a:noFill/>
+                    </a:lnL>
+                    <a:lnR>
+                      <a:noFill/>
+                    </a:lnR>
+                    <a:lnT>
+                      <a:noFill/>
+                    </a:lnT>
+                    <a:lnB>
+                      <a:noFill/>
+                    </a:lnB>
+                  </a:tcPr>
+                </a:tc>
+                <a:tc>
+                  <a:txBody>
+                    <a:bodyPr/>
+                    <a:lstStyle/>
+                    <a:p>
+                      <a:r>
+                        <a:rPr lang="en-IN" sz="2000" b="1"/>
+                        <a:t>68</a:t>
+                      </a:r>
+                    </a:p>
+                  </a:txBody>
+                  <a:tcPr anchor="ctr">
+                    <a:lnL>
+                      <a:noFill/>
+                    </a:lnL>
+                    <a:lnR>
+                      <a:noFill/>
+                    </a:lnR>
+                    <a:lnT>
+                      <a:noFill/>
+                    </a:lnT>
+                    <a:lnB>
+                      <a:noFill/>
+                    </a:lnB>
+                  </a:tcPr>
+                </a:tc>
+                <a:extLst>
+                  <a:ext uri="{0D108BD9-81ED-4DB2-BD59-A6C34878D82A}">
+                    <a16:rowId xmlns:a16="http://schemas.microsoft.com/office/drawing/2014/main" val="3997077680"/>
+                  </a:ext>
+                </a:extLst>
+              </a:tr>
+              <a:tr h="0">
+                <a:tc>
+                  <a:txBody>
+                    <a:bodyPr/>
+                    <a:lstStyle/>
+                    <a:p>
+                      <a:r>
+                        <a:rPr lang="en-IN" sz="2000" b="1"/>
+                        <a:t>Priya</a:t>
+                      </a:r>
+                    </a:p>
+                  </a:txBody>
+                  <a:tcPr anchor="ctr">
+                    <a:lnL>
+                      <a:noFill/>
+                    </a:lnL>
+                    <a:lnR>
+                      <a:noFill/>
+                    </a:lnR>
+                    <a:lnT>
+                      <a:noFill/>
+                    </a:lnT>
+                    <a:lnB>
+                      <a:noFill/>
+                    </a:lnB>
+                  </a:tcPr>
+                </a:tc>
+                <a:tc>
+                  <a:txBody>
+                    <a:bodyPr/>
+                    <a:lstStyle/>
+                    <a:p>
+                      <a:r>
+                        <a:rPr lang="en-IN" sz="2000" b="1"/>
+                        <a:t>92</a:t>
+                      </a:r>
+                    </a:p>
+                  </a:txBody>
+                  <a:tcPr anchor="ctr">
+                    <a:lnL>
+                      <a:noFill/>
+                    </a:lnL>
+                    <a:lnR>
+                      <a:noFill/>
+                    </a:lnR>
+                    <a:lnT>
+                      <a:noFill/>
+                    </a:lnT>
+                    <a:lnB>
+                      <a:noFill/>
+                    </a:lnB>
+                  </a:tcPr>
+                </a:tc>
+                <a:tc>
+                  <a:txBody>
+                    <a:bodyPr/>
+                    <a:lstStyle/>
+                    <a:p>
+                      <a:r>
+                        <a:rPr lang="en-IN" sz="2000" b="1"/>
+                        <a:t>88</a:t>
+                      </a:r>
+                    </a:p>
+                  </a:txBody>
+                  <a:tcPr anchor="ctr">
+                    <a:lnL>
+                      <a:noFill/>
+                    </a:lnL>
+                    <a:lnR>
+                      <a:noFill/>
+                    </a:lnR>
+                    <a:lnT>
+                      <a:noFill/>
+                    </a:lnT>
+                    <a:lnB>
+                      <a:noFill/>
+                    </a:lnB>
+                  </a:tcPr>
+                </a:tc>
+                <a:tc>
+                  <a:txBody>
+                    <a:bodyPr/>
+                    <a:lstStyle/>
+                    <a:p>
+                      <a:r>
+                        <a:rPr lang="en-IN" sz="2000" b="1"/>
+                        <a:t>95</a:t>
+                      </a:r>
+                    </a:p>
+                  </a:txBody>
+                  <a:tcPr anchor="ctr">
+                    <a:lnL>
+                      <a:noFill/>
+                    </a:lnL>
+                    <a:lnR>
+                      <a:noFill/>
+                    </a:lnR>
+                    <a:lnT>
+                      <a:noFill/>
+                    </a:lnT>
+                    <a:lnB>
+                      <a:noFill/>
+                    </a:lnB>
+                  </a:tcPr>
+                </a:tc>
+                <a:extLst>
+                  <a:ext uri="{0D108BD9-81ED-4DB2-BD59-A6C34878D82A}">
+                    <a16:rowId xmlns:a16="http://schemas.microsoft.com/office/drawing/2014/main" val="1415033293"/>
+                  </a:ext>
+                </a:extLst>
+              </a:tr>
+              <a:tr h="0">
+                <a:tc>
+                  <a:txBody>
+                    <a:bodyPr/>
+                    <a:lstStyle/>
+                    <a:p>
+                      <a:r>
+                        <a:rPr lang="en-IN" sz="2000" b="1"/>
+                        <a:t>Ankit</a:t>
+                      </a:r>
+                    </a:p>
+                  </a:txBody>
+                  <a:tcPr anchor="ctr">
+                    <a:lnL>
+                      <a:noFill/>
+                    </a:lnL>
+                    <a:lnR>
+                      <a:noFill/>
+                    </a:lnR>
+                    <a:lnT>
+                      <a:noFill/>
+                    </a:lnT>
+                    <a:lnB>
+                      <a:noFill/>
+                    </a:lnB>
+                  </a:tcPr>
+                </a:tc>
+                <a:tc>
+                  <a:txBody>
+                    <a:bodyPr/>
+                    <a:lstStyle/>
+                    <a:p>
+                      <a:r>
+                        <a:rPr lang="en-IN" sz="2000" b="1"/>
+                        <a:t>75</a:t>
+                      </a:r>
+                    </a:p>
+                  </a:txBody>
+                  <a:tcPr anchor="ctr">
+                    <a:lnL>
+                      <a:noFill/>
+                    </a:lnL>
+                    <a:lnR>
+                      <a:noFill/>
+                    </a:lnR>
+                    <a:lnT>
+                      <a:noFill/>
+                    </a:lnT>
+                    <a:lnB>
+                      <a:noFill/>
+                    </a:lnB>
+                  </a:tcPr>
+                </a:tc>
+                <a:tc>
+                  <a:txBody>
+                    <a:bodyPr/>
+                    <a:lstStyle/>
+                    <a:p>
+                      <a:r>
+                        <a:rPr lang="en-IN" sz="2000" b="1"/>
+                        <a:t>82</a:t>
+                      </a:r>
+                    </a:p>
+                  </a:txBody>
+                  <a:tcPr anchor="ctr">
+                    <a:lnL>
+                      <a:noFill/>
+                    </a:lnL>
+                    <a:lnR>
+                      <a:noFill/>
+                    </a:lnR>
+                    <a:lnT>
+                      <a:noFill/>
+                    </a:lnT>
+                    <a:lnB>
+                      <a:noFill/>
+                    </a:lnB>
+                  </a:tcPr>
+                </a:tc>
+                <a:tc>
+                  <a:txBody>
+                    <a:bodyPr/>
+                    <a:lstStyle/>
+                    <a:p>
+                      <a:r>
+                        <a:rPr lang="en-IN" sz="2000" b="1" dirty="0"/>
+                        <a:t>78</a:t>
+                      </a:r>
+                    </a:p>
+                  </a:txBody>
+                  <a:tcPr anchor="ctr">
+                    <a:lnL>
+                      <a:noFill/>
+                    </a:lnL>
+                    <a:lnR>
+                      <a:noFill/>
+                    </a:lnR>
+                    <a:lnT>
+                      <a:noFill/>
+                    </a:lnT>
+                    <a:lnB>
+                      <a:noFill/>
+                    </a:lnB>
+                  </a:tcPr>
+                </a:tc>
+                <a:extLst>
+                  <a:ext uri="{0D108BD9-81ED-4DB2-BD59-A6C34878D82A}">
+                    <a16:rowId xmlns:a16="http://schemas.microsoft.com/office/drawing/2014/main" val="2743273851"/>
+                  </a:ext>
+                </a:extLst>
+              </a:tr>
+            </a:tbl>
+          </a:graphicData>
+        </a:graphic>
+      </p:graphicFrame>
     </p:spTree>
     <p:extLst>
       <p:ext uri="{BB962C8B-B14F-4D97-AF65-F5344CB8AC3E}">
-        <p14:creationId xmlns:p14="http://schemas.microsoft.com/office/powerpoint/2010/main" val="158702206"/>
+        <p14:creationId xmlns:p14="http://schemas.microsoft.com/office/powerpoint/2010/main" val="4115638078"/>
       </p:ext>
     </p:extLst>
   </p:cSld>
@@ -6435,10 +7965,10 @@
       </p:grpSpPr>
       <p:sp>
         <p:nvSpPr>
-          <p:cNvPr id="2" name="Oval 1">
+          <p:cNvPr id="8" name="Oval 7">
             <a:extLst>
               <a:ext uri="{FF2B5EF4-FFF2-40B4-BE49-F238E27FC236}">
-                <a16:creationId xmlns:a16="http://schemas.microsoft.com/office/drawing/2014/main" id="{14817208-43A0-4277-ACFA-AFE30CEF256B}"/>
+                <a16:creationId xmlns:a16="http://schemas.microsoft.com/office/drawing/2014/main" id="{DD19CF32-87B5-402D-8EA7-7E9BA1060AE0}"/>
               </a:ext>
             </a:extLst>
           </p:cNvPr>
@@ -6447,7 +7977,7 @@
         </p:nvSpPr>
         <p:spPr>
           <a:xfrm>
-            <a:off x="509285" y="1798416"/>
+            <a:off x="1064870" y="1705819"/>
             <a:ext cx="3472405" cy="3446362"/>
           </a:xfrm>
           <a:prstGeom prst="ellipse">
@@ -6495,7 +8025,7 @@
                   <a:srgbClr val="FF0000"/>
                 </a:solidFill>
               </a:rPr>
-              <a:t>Task 4 : Create A Chart</a:t>
+              <a:t>Task 4 : Create Pie Chart</a:t>
             </a:r>
             <a:endParaRPr lang="en-IN" sz="2400" b="1" dirty="0">
               <a:solidFill>
@@ -6505,76 +8035,412 @@
           </a:p>
         </p:txBody>
       </p:sp>
-      <p:pic>
-        <p:nvPicPr>
-          <p:cNvPr id="4" name="Picture 3">
+      <p:graphicFrame>
+        <p:nvGraphicFramePr>
+          <p:cNvPr id="10" name="Table 9">
             <a:extLst>
               <a:ext uri="{FF2B5EF4-FFF2-40B4-BE49-F238E27FC236}">
-                <a16:creationId xmlns:a16="http://schemas.microsoft.com/office/drawing/2014/main" id="{B1698C17-3F66-4322-AF30-44D3ED934F9C}"/>
+                <a16:creationId xmlns:a16="http://schemas.microsoft.com/office/drawing/2014/main" id="{39D8680E-4529-4473-B4DD-D55AA318D479}"/>
               </a:ext>
             </a:extLst>
           </p:cNvPr>
-          <p:cNvPicPr>
-            <a:picLocks noChangeAspect="1"/>
-          </p:cNvPicPr>
-          <p:nvPr/>
-        </p:nvPicPr>
-        <p:blipFill>
-          <a:blip r:embed="rId2">
-            <a:extLst>
-              <a:ext uri="{28A0092B-C50C-407E-A947-70E740481C1C}">
-                <a14:useLocalDpi xmlns:a14="http://schemas.microsoft.com/office/drawing/2010/main" val="0"/>
-              </a:ext>
-            </a:extLst>
-          </a:blip>
-          <a:stretch>
-            <a:fillRect/>
-          </a:stretch>
-        </p:blipFill>
-        <p:spPr>
-          <a:xfrm>
-            <a:off x="5241069" y="2026"/>
-            <a:ext cx="6950931" cy="6855974"/>
-          </a:xfrm>
-          <a:prstGeom prst="rect">
-            <a:avLst/>
-          </a:prstGeom>
-          <a:solidFill>
-            <a:srgbClr val="FFFFFF">
-              <a:shade val="85000"/>
-            </a:srgbClr>
-          </a:solidFill>
-          <a:ln w="88900" cap="sq">
-            <a:solidFill>
-              <a:srgbClr val="FFFFFF"/>
-            </a:solidFill>
-            <a:miter lim="800000"/>
-          </a:ln>
-          <a:effectLst>
-            <a:outerShdw blurRad="55000" dist="18000" dir="5400000" algn="tl" rotWithShape="0">
-              <a:srgbClr val="000000">
-                <a:alpha val="40000"/>
-              </a:srgbClr>
-            </a:outerShdw>
-          </a:effectLst>
-          <a:scene3d>
-            <a:camera prst="orthographicFront"/>
-            <a:lightRig rig="twoPt" dir="t">
-              <a:rot lat="0" lon="0" rev="7200000"/>
-            </a:lightRig>
-          </a:scene3d>
-          <a:sp3d>
-            <a:bevelT w="25400" h="19050"/>
-            <a:contourClr>
-              <a:srgbClr val="FFFFFF"/>
-            </a:contourClr>
-          </a:sp3d>
-        </p:spPr>
-      </p:pic>
+          <p:cNvGraphicFramePr>
+            <a:graphicFrameLocks noGrp="1"/>
+          </p:cNvGraphicFramePr>
+          <p:nvPr>
+            <p:extLst>
+              <p:ext uri="{D42A27DB-BD31-4B8C-83A1-F6EECF244321}">
+                <p14:modId xmlns:p14="http://schemas.microsoft.com/office/powerpoint/2010/main" val="1123552382"/>
+              </p:ext>
+            </p:extLst>
+          </p:nvPr>
+        </p:nvGraphicFramePr>
+        <p:xfrm>
+          <a:off x="4807059" y="2331720"/>
+          <a:ext cx="5695336" cy="2377440"/>
+        </p:xfrm>
+        <a:graphic>
+          <a:graphicData uri="http://schemas.openxmlformats.org/drawingml/2006/table">
+            <a:tbl>
+              <a:tblPr/>
+              <a:tblGrid>
+                <a:gridCol w="2847668">
+                  <a:extLst>
+                    <a:ext uri="{9D8B030D-6E8A-4147-A177-3AD203B41FA5}">
+                      <a16:colId xmlns:a16="http://schemas.microsoft.com/office/drawing/2014/main" val="522161317"/>
+                    </a:ext>
+                  </a:extLst>
+                </a:gridCol>
+                <a:gridCol w="2847668">
+                  <a:extLst>
+                    <a:ext uri="{9D8B030D-6E8A-4147-A177-3AD203B41FA5}">
+                      <a16:colId xmlns:a16="http://schemas.microsoft.com/office/drawing/2014/main" val="3474070828"/>
+                    </a:ext>
+                  </a:extLst>
+                </a:gridCol>
+              </a:tblGrid>
+              <a:tr h="0">
+                <a:tc>
+                  <a:txBody>
+                    <a:bodyPr/>
+                    <a:lstStyle/>
+                    <a:p>
+                      <a:r>
+                        <a:rPr lang="en-IN" sz="2000" b="1"/>
+                        <a:t>Category</a:t>
+                      </a:r>
+                    </a:p>
+                  </a:txBody>
+                  <a:tcPr anchor="ctr">
+                    <a:lnL>
+                      <a:noFill/>
+                    </a:lnL>
+                    <a:lnR>
+                      <a:noFill/>
+                    </a:lnR>
+                    <a:lnT>
+                      <a:noFill/>
+                    </a:lnT>
+                    <a:lnB>
+                      <a:noFill/>
+                    </a:lnB>
+                  </a:tcPr>
+                </a:tc>
+                <a:tc>
+                  <a:txBody>
+                    <a:bodyPr/>
+                    <a:lstStyle/>
+                    <a:p>
+                      <a:r>
+                        <a:rPr lang="en-IN" sz="2000" b="1"/>
+                        <a:t>Amount (₹)</a:t>
+                      </a:r>
+                    </a:p>
+                  </a:txBody>
+                  <a:tcPr anchor="ctr">
+                    <a:lnL>
+                      <a:noFill/>
+                    </a:lnL>
+                    <a:lnR>
+                      <a:noFill/>
+                    </a:lnR>
+                    <a:lnT>
+                      <a:noFill/>
+                    </a:lnT>
+                    <a:lnB>
+                      <a:noFill/>
+                    </a:lnB>
+                  </a:tcPr>
+                </a:tc>
+                <a:extLst>
+                  <a:ext uri="{0D108BD9-81ED-4DB2-BD59-A6C34878D82A}">
+                    <a16:rowId xmlns:a16="http://schemas.microsoft.com/office/drawing/2014/main" val="2442989589"/>
+                  </a:ext>
+                </a:extLst>
+              </a:tr>
+              <a:tr h="0">
+                <a:tc>
+                  <a:txBody>
+                    <a:bodyPr/>
+                    <a:lstStyle/>
+                    <a:p>
+                      <a:r>
+                        <a:rPr lang="en-IN" sz="2000" b="1"/>
+                        <a:t>Rent</a:t>
+                      </a:r>
+                    </a:p>
+                  </a:txBody>
+                  <a:tcPr anchor="ctr">
+                    <a:lnL>
+                      <a:noFill/>
+                    </a:lnL>
+                    <a:lnR>
+                      <a:noFill/>
+                    </a:lnR>
+                    <a:lnT>
+                      <a:noFill/>
+                    </a:lnT>
+                    <a:lnB>
+                      <a:noFill/>
+                    </a:lnB>
+                  </a:tcPr>
+                </a:tc>
+                <a:tc>
+                  <a:txBody>
+                    <a:bodyPr/>
+                    <a:lstStyle/>
+                    <a:p>
+                      <a:r>
+                        <a:rPr lang="en-IN" sz="2000" b="1"/>
+                        <a:t>8000</a:t>
+                      </a:r>
+                    </a:p>
+                  </a:txBody>
+                  <a:tcPr anchor="ctr">
+                    <a:lnL>
+                      <a:noFill/>
+                    </a:lnL>
+                    <a:lnR>
+                      <a:noFill/>
+                    </a:lnR>
+                    <a:lnT>
+                      <a:noFill/>
+                    </a:lnT>
+                    <a:lnB>
+                      <a:noFill/>
+                    </a:lnB>
+                  </a:tcPr>
+                </a:tc>
+                <a:extLst>
+                  <a:ext uri="{0D108BD9-81ED-4DB2-BD59-A6C34878D82A}">
+                    <a16:rowId xmlns:a16="http://schemas.microsoft.com/office/drawing/2014/main" val="3993553013"/>
+                  </a:ext>
+                </a:extLst>
+              </a:tr>
+              <a:tr h="0">
+                <a:tc>
+                  <a:txBody>
+                    <a:bodyPr/>
+                    <a:lstStyle/>
+                    <a:p>
+                      <a:r>
+                        <a:rPr lang="en-IN" sz="2000" b="1" dirty="0"/>
+                        <a:t>Food</a:t>
+                      </a:r>
+                    </a:p>
+                  </a:txBody>
+                  <a:tcPr anchor="ctr">
+                    <a:lnL>
+                      <a:noFill/>
+                    </a:lnL>
+                    <a:lnR>
+                      <a:noFill/>
+                    </a:lnR>
+                    <a:lnT>
+                      <a:noFill/>
+                    </a:lnT>
+                    <a:lnB>
+                      <a:noFill/>
+                    </a:lnB>
+                  </a:tcPr>
+                </a:tc>
+                <a:tc>
+                  <a:txBody>
+                    <a:bodyPr/>
+                    <a:lstStyle/>
+                    <a:p>
+                      <a:r>
+                        <a:rPr lang="en-IN" sz="2000" b="1"/>
+                        <a:t>4000</a:t>
+                      </a:r>
+                    </a:p>
+                  </a:txBody>
+                  <a:tcPr anchor="ctr">
+                    <a:lnL>
+                      <a:noFill/>
+                    </a:lnL>
+                    <a:lnR>
+                      <a:noFill/>
+                    </a:lnR>
+                    <a:lnT>
+                      <a:noFill/>
+                    </a:lnT>
+                    <a:lnB>
+                      <a:noFill/>
+                    </a:lnB>
+                  </a:tcPr>
+                </a:tc>
+                <a:extLst>
+                  <a:ext uri="{0D108BD9-81ED-4DB2-BD59-A6C34878D82A}">
+                    <a16:rowId xmlns:a16="http://schemas.microsoft.com/office/drawing/2014/main" val="2170107327"/>
+                  </a:ext>
+                </a:extLst>
+              </a:tr>
+              <a:tr h="0">
+                <a:tc>
+                  <a:txBody>
+                    <a:bodyPr/>
+                    <a:lstStyle/>
+                    <a:p>
+                      <a:r>
+                        <a:rPr lang="en-IN" sz="2000" b="1"/>
+                        <a:t>Transport</a:t>
+                      </a:r>
+                    </a:p>
+                  </a:txBody>
+                  <a:tcPr anchor="ctr">
+                    <a:lnL>
+                      <a:noFill/>
+                    </a:lnL>
+                    <a:lnR>
+                      <a:noFill/>
+                    </a:lnR>
+                    <a:lnT>
+                      <a:noFill/>
+                    </a:lnT>
+                    <a:lnB>
+                      <a:noFill/>
+                    </a:lnB>
+                  </a:tcPr>
+                </a:tc>
+                <a:tc>
+                  <a:txBody>
+                    <a:bodyPr/>
+                    <a:lstStyle/>
+                    <a:p>
+                      <a:r>
+                        <a:rPr lang="en-IN" sz="2000" b="1"/>
+                        <a:t>2000</a:t>
+                      </a:r>
+                    </a:p>
+                  </a:txBody>
+                  <a:tcPr anchor="ctr">
+                    <a:lnL>
+                      <a:noFill/>
+                    </a:lnL>
+                    <a:lnR>
+                      <a:noFill/>
+                    </a:lnR>
+                    <a:lnT>
+                      <a:noFill/>
+                    </a:lnT>
+                    <a:lnB>
+                      <a:noFill/>
+                    </a:lnB>
+                  </a:tcPr>
+                </a:tc>
+                <a:extLst>
+                  <a:ext uri="{0D108BD9-81ED-4DB2-BD59-A6C34878D82A}">
+                    <a16:rowId xmlns:a16="http://schemas.microsoft.com/office/drawing/2014/main" val="1157588435"/>
+                  </a:ext>
+                </a:extLst>
+              </a:tr>
+              <a:tr h="0">
+                <a:tc>
+                  <a:txBody>
+                    <a:bodyPr/>
+                    <a:lstStyle/>
+                    <a:p>
+                      <a:r>
+                        <a:rPr lang="en-IN" sz="2000" b="1"/>
+                        <a:t>Entertainment</a:t>
+                      </a:r>
+                    </a:p>
+                  </a:txBody>
+                  <a:tcPr anchor="ctr">
+                    <a:lnL>
+                      <a:noFill/>
+                    </a:lnL>
+                    <a:lnR>
+                      <a:noFill/>
+                    </a:lnR>
+                    <a:lnT>
+                      <a:noFill/>
+                    </a:lnT>
+                    <a:lnB>
+                      <a:noFill/>
+                    </a:lnB>
+                  </a:tcPr>
+                </a:tc>
+                <a:tc>
+                  <a:txBody>
+                    <a:bodyPr/>
+                    <a:lstStyle/>
+                    <a:p>
+                      <a:r>
+                        <a:rPr lang="en-IN" sz="2000" b="1"/>
+                        <a:t>1500</a:t>
+                      </a:r>
+                    </a:p>
+                  </a:txBody>
+                  <a:tcPr anchor="ctr">
+                    <a:lnL>
+                      <a:noFill/>
+                    </a:lnL>
+                    <a:lnR>
+                      <a:noFill/>
+                    </a:lnR>
+                    <a:lnT>
+                      <a:noFill/>
+                    </a:lnT>
+                    <a:lnB>
+                      <a:noFill/>
+                    </a:lnB>
+                  </a:tcPr>
+                </a:tc>
+                <a:extLst>
+                  <a:ext uri="{0D108BD9-81ED-4DB2-BD59-A6C34878D82A}">
+                    <a16:rowId xmlns:a16="http://schemas.microsoft.com/office/drawing/2014/main" val="451438903"/>
+                  </a:ext>
+                </a:extLst>
+              </a:tr>
+              <a:tr h="0">
+                <a:tc>
+                  <a:txBody>
+                    <a:bodyPr/>
+                    <a:lstStyle/>
+                    <a:p>
+                      <a:r>
+                        <a:rPr lang="en-IN" sz="2000" b="1"/>
+                        <a:t>Savings</a:t>
+                      </a:r>
+                    </a:p>
+                  </a:txBody>
+                  <a:tcPr anchor="ctr">
+                    <a:lnL>
+                      <a:noFill/>
+                    </a:lnL>
+                    <a:lnR>
+                      <a:noFill/>
+                    </a:lnR>
+                    <a:lnT>
+                      <a:noFill/>
+                    </a:lnT>
+                    <a:lnB>
+                      <a:noFill/>
+                    </a:lnB>
+                  </a:tcPr>
+                </a:tc>
+                <a:tc>
+                  <a:txBody>
+                    <a:bodyPr/>
+                    <a:lstStyle/>
+                    <a:p>
+                      <a:r>
+                        <a:rPr lang="en-IN" sz="2000" b="1" dirty="0"/>
+                        <a:t>3500</a:t>
+                      </a:r>
+                    </a:p>
+                  </a:txBody>
+                  <a:tcPr anchor="ctr">
+                    <a:lnL>
+                      <a:noFill/>
+                    </a:lnL>
+                    <a:lnR>
+                      <a:noFill/>
+                    </a:lnR>
+                    <a:lnT>
+                      <a:noFill/>
+                    </a:lnT>
+                    <a:lnB>
+                      <a:noFill/>
+                    </a:lnB>
+                  </a:tcPr>
+                </a:tc>
+                <a:extLst>
+                  <a:ext uri="{0D108BD9-81ED-4DB2-BD59-A6C34878D82A}">
+                    <a16:rowId xmlns:a16="http://schemas.microsoft.com/office/drawing/2014/main" val="3219420574"/>
+                  </a:ext>
+                </a:extLst>
+              </a:tr>
+            </a:tbl>
+          </a:graphicData>
+        </a:graphic>
+      </p:graphicFrame>
     </p:spTree>
     <p:extLst>
       <p:ext uri="{BB962C8B-B14F-4D97-AF65-F5344CB8AC3E}">
-        <p14:creationId xmlns:p14="http://schemas.microsoft.com/office/powerpoint/2010/main" val="4079808065"/>
+        <p14:creationId xmlns:p14="http://schemas.microsoft.com/office/powerpoint/2010/main" val="59337256"/>
       </p:ext>
     </p:extLst>
   </p:cSld>
@@ -6616,7 +8482,7 @@
         <p:spPr>
           <a:xfrm>
             <a:off x="613458" y="1566922"/>
-            <a:ext cx="10718157" cy="3446362"/>
+            <a:ext cx="10998439" cy="3446362"/>
           </a:xfrm>
           <a:prstGeom prst="ellipse">
             <a:avLst/>
@@ -6663,22 +8529,19 @@
                   <a:srgbClr val="FF0000"/>
                 </a:solidFill>
               </a:rPr>
-              <a:t>Task 5 : Do Mail Merge With One </a:t>
-            </a:r>
-          </a:p>
-          <a:p>
-            <a:pPr algn="ctr"/>
+              <a:t>Task 5 : </a:t>
+            </a:r>
             <a:r>
               <a:rPr lang="en-US" sz="2400" b="1" dirty="0">
                 <a:solidFill>
-                  <a:srgbClr val="FF0000"/>
+                  <a:schemeClr val="tx1"/>
                 </a:solidFill>
               </a:rPr>
-              <a:t>Any one Example</a:t>
+              <a:t>Convert This Data into Excel Table and Apply Remove Duplicates and Filters and Sorting</a:t>
             </a:r>
             <a:endParaRPr lang="en-IN" sz="2400" b="1" dirty="0">
               <a:solidFill>
-                <a:srgbClr val="FF0000"/>
+                <a:schemeClr val="tx1"/>
               </a:solidFill>
             </a:endParaRPr>
           </a:p>
@@ -6774,8 +8637,8 @@
         </p:nvSpPr>
         <p:spPr>
           <a:xfrm>
-            <a:off x="698090" y="1415845"/>
-            <a:ext cx="11002297" cy="4801314"/>
+            <a:off x="3018503" y="1946788"/>
+            <a:ext cx="6292645" cy="2677656"/>
           </a:xfrm>
           <a:prstGeom prst="rect">
             <a:avLst/>
@@ -6789,86 +8652,41 @@
           <a:lstStyle/>
           <a:p>
             <a:r>
-              <a:rPr lang="en-US" b="1" dirty="0"/>
-              <a:t>To,  </a:t>
-            </a:r>
-          </a:p>
-          <a:p>
-            <a:r>
-              <a:rPr lang="en-US" b="1" dirty="0"/>
-              <a:t>The Manager,  </a:t>
-            </a:r>
-          </a:p>
-          <a:p>
-            <a:r>
-              <a:rPr lang="en-US" b="1" dirty="0" err="1"/>
-              <a:t>Cadd</a:t>
-            </a:r>
-            <a:r>
-              <a:rPr lang="en-US" b="1" dirty="0"/>
-              <a:t> Mentor Bareilly</a:t>
-            </a:r>
-          </a:p>
-          <a:p>
-            <a:endParaRPr lang="en-US" b="1" dirty="0"/>
-          </a:p>
-          <a:p>
-            <a:r>
-              <a:rPr lang="en-US" b="1" dirty="0"/>
-              <a:t>Subject: Application for Leave  </a:t>
-            </a:r>
-          </a:p>
-          <a:p>
-            <a:endParaRPr lang="en-US" b="1" dirty="0"/>
-          </a:p>
-          <a:p>
-            <a:r>
-              <a:rPr lang="en-US" b="1" dirty="0"/>
-              <a:t>Respected Sir/Madam,  </a:t>
-            </a:r>
-          </a:p>
-          <a:p>
-            <a:endParaRPr lang="en-US" b="1" dirty="0"/>
-          </a:p>
-          <a:p>
-            <a:r>
-              <a:rPr lang="en-US" b="1" dirty="0"/>
-              <a:t>My name is &lt;&lt;Rohan&gt;&gt;. I am writing this application to request leave due to personal reasons.  </a:t>
-            </a:r>
-          </a:p>
-          <a:p>
-            <a:endParaRPr lang="en-US" b="1" dirty="0"/>
-          </a:p>
-          <a:p>
-            <a:r>
-              <a:rPr lang="en-US" b="1" dirty="0"/>
-              <a:t>Kindly grant me leave. You can contact me if needed on my phone number &lt;&lt;1234567890&gt;&gt; or email &lt;&lt;rohan@rohan.com&gt;&gt;.  </a:t>
-            </a:r>
-          </a:p>
-          <a:p>
-            <a:endParaRPr lang="en-US" b="1" dirty="0"/>
-          </a:p>
-          <a:p>
-            <a:r>
-              <a:rPr lang="en-US" b="1" dirty="0"/>
-              <a:t>I shall be thankful to you.  </a:t>
-            </a:r>
-          </a:p>
-          <a:p>
-            <a:endParaRPr lang="en-US" b="1" dirty="0"/>
-          </a:p>
-          <a:p>
-            <a:r>
-              <a:rPr lang="en-US" b="1" dirty="0"/>
-              <a:t>Yours sincerely,  </a:t>
-            </a:r>
-          </a:p>
-          <a:p>
-            <a:r>
-              <a:rPr lang="en-US" b="1" dirty="0"/>
-              <a:t>&lt;&lt;Rohan&gt;&gt;</a:t>
-            </a:r>
-            <a:endParaRPr lang="en-IN" b="1" dirty="0"/>
+              <a:rPr lang="en-US" sz="2800" b="1" dirty="0" err="1"/>
+              <a:t>CityID,StateID,State,City,Population</a:t>
+            </a:r>
+            <a:endParaRPr lang="en-US" sz="2800" b="1" dirty="0"/>
+          </a:p>
+          <a:p>
+            <a:r>
+              <a:rPr lang="en-US" sz="2800" b="1" dirty="0"/>
+              <a:t>1,3,Delhi,New Delhi,8571051</a:t>
+            </a:r>
+          </a:p>
+          <a:p>
+            <a:r>
+              <a:rPr lang="en-US" sz="2800" b="1" dirty="0"/>
+              <a:t>2,9,Maharashtra,Mumbai,3191630</a:t>
+            </a:r>
+          </a:p>
+          <a:p>
+            <a:r>
+              <a:rPr lang="en-US" sz="2800" b="1" dirty="0"/>
+              <a:t>2,9,Maharashtra,Mumbai,3191630</a:t>
+            </a:r>
+          </a:p>
+          <a:p>
+            <a:r>
+              <a:rPr lang="en-US" sz="2800" b="1" dirty="0"/>
+              <a:t>4,6,Karnataka,Bengaluru,4211045</a:t>
+            </a:r>
+          </a:p>
+          <a:p>
+            <a:r>
+              <a:rPr lang="en-US" sz="2800" b="1" dirty="0"/>
+              <a:t>5,6,Karnataka,Mysuru,2927616</a:t>
+            </a:r>
+            <a:endParaRPr lang="en-IN" sz="2800" b="1" dirty="0"/>
           </a:p>
         </p:txBody>
       </p:sp>

</xml_diff>